<commit_message>
Añadidas las slides faltantes de la ppt (pendientes de completar con los resultados y la conclusión
</commit_message>
<xml_diff>
--- a/docs/TP5_Simulacion_Grupo4.pptx
+++ b/docs/TP5_Simulacion_Grupo4.pptx
@@ -15,6 +15,18 @@
     <p:sldId id="264" r:id="rId9"/>
     <p:sldId id="266" r:id="rId10"/>
     <p:sldId id="268" r:id="rId11"/>
+    <p:sldId id="275" r:id="rId12"/>
+    <p:sldId id="276" r:id="rId13"/>
+    <p:sldId id="269" r:id="rId14"/>
+    <p:sldId id="270" r:id="rId15"/>
+    <p:sldId id="271" r:id="rId16"/>
+    <p:sldId id="272" r:id="rId17"/>
+    <p:sldId id="273" r:id="rId18"/>
+    <p:sldId id="274" r:id="rId19"/>
+    <p:sldId id="277" r:id="rId20"/>
+    <p:sldId id="278" r:id="rId21"/>
+    <p:sldId id="279" r:id="rId22"/>
+    <p:sldId id="280" r:id="rId23"/>
   </p:sldIdLst>
   <p:sldSz cx="12192000" cy="6858000"/>
   <p:notesSz cx="6858000" cy="9144000"/>
@@ -121,6 +133,142 @@
 </p:presentation>
 </file>
 
+<file path=ppt/authors.xml><?xml version="1.0" encoding="utf-8"?>
+<p188:authorLst xmlns:a="http://schemas.openxmlformats.org/drawingml/2006/main" xmlns:r="http://schemas.openxmlformats.org/officeDocument/2006/relationships" xmlns:p188="http://schemas.microsoft.com/office/powerpoint/2018/8/main">
+  <p188:author id="{B464C5B0-C227-F21D-B2F1-7674ACFE52EF}" name="Guillermo Federico CACACE" initials="GC" userId="a541a8ba38776122" providerId="Windows Live"/>
+</p188:authorLst>
+</file>
+
+<file path=ppt/comments/modernComment_10D_EE689C95.xml><?xml version="1.0" encoding="utf-8"?>
+<p188:cmLst xmlns:a="http://schemas.openxmlformats.org/drawingml/2006/main" xmlns:r="http://schemas.openxmlformats.org/officeDocument/2006/relationships" xmlns:p188="http://schemas.microsoft.com/office/powerpoint/2018/8/main">
+  <p188:cm id="{10B9BFF6-D75F-4043-90E9-7C762FB25D54}" authorId="{B464C5B0-C227-F21D-B2F1-7674ACFE52EF}" created="2026-05-25T14:55:06.334">
+    <ac:txMkLst xmlns:ac="http://schemas.microsoft.com/office/drawing/2013/main/command">
+      <pc:docMk xmlns:pc="http://schemas.microsoft.com/office/powerpoint/2013/main/command"/>
+      <pc:sldMk xmlns:pc="http://schemas.microsoft.com/office/powerpoint/2013/main/command" cId="3999833237" sldId="269"/>
+      <ac:spMk id="2" creationId="{79B7201B-781D-B10D-7090-2248D1CA71B8}"/>
+      <ac:txMk cp="22" len="4">
+        <ac:context len="27" hash="308980807"/>
+      </ac:txMk>
+    </ac:txMkLst>
+    <p188:pos x="8163531" y="400050"/>
+    <p188:txBody>
+      <a:bodyPr/>
+      <a:lstStyle/>
+      <a:p>
+        <a:r>
+          <a:rPr lang="es-AR"/>
+          <a:t>Grafico torta UDP vs TCP</a:t>
+        </a:r>
+      </a:p>
+    </p188:txBody>
+  </p188:cm>
+</p188:cmLst>
+</file>
+
+<file path=ppt/comments/modernComment_10F_C7AC22BB.xml><?xml version="1.0" encoding="utf-8"?>
+<p188:cmLst xmlns:a="http://schemas.openxmlformats.org/drawingml/2006/main" xmlns:r="http://schemas.openxmlformats.org/officeDocument/2006/relationships" xmlns:p188="http://schemas.microsoft.com/office/powerpoint/2018/8/main">
+  <p188:cm id="{3044A2DD-00ED-4B4B-A2A2-665F720C1733}" authorId="{B464C5B0-C227-F21D-B2F1-7674ACFE52EF}" created="2026-05-25T14:55:06.334">
+    <ac:txMkLst xmlns:ac="http://schemas.microsoft.com/office/drawing/2013/main/command">
+      <pc:docMk xmlns:pc="http://schemas.microsoft.com/office/powerpoint/2013/main/command"/>
+      <pc:sldMk xmlns:pc="http://schemas.microsoft.com/office/powerpoint/2013/main/command" cId="3349947067" sldId="271"/>
+      <ac:spMk id="2" creationId="{74FF1088-6BD5-58E8-0C5D-5288E3148F07}"/>
+      <ac:txMk cp="0" len="1">
+        <ac:context len="44" hash="2572100193"/>
+      </ac:txMk>
+    </ac:txMkLst>
+    <p188:pos x="8163531" y="400050"/>
+    <p188:txBody>
+      <a:bodyPr/>
+      <a:lstStyle/>
+      <a:p>
+        <a:r>
+          <a:rPr lang="es-AR"/>
+          <a:t>Grafico torta UDP vs TCP</a:t>
+        </a:r>
+      </a:p>
+    </p188:txBody>
+  </p188:cm>
+</p188:cmLst>
+</file>
+
+<file path=ppt/comments/modernComment_111_E873365D.xml><?xml version="1.0" encoding="utf-8"?>
+<p188:cmLst xmlns:a="http://schemas.openxmlformats.org/drawingml/2006/main" xmlns:r="http://schemas.openxmlformats.org/officeDocument/2006/relationships" xmlns:p188="http://schemas.microsoft.com/office/powerpoint/2018/8/main">
+  <p188:cm id="{D280EB07-4417-49D9-9445-6E49EF13CA0B}" authorId="{B464C5B0-C227-F21D-B2F1-7674ACFE52EF}" created="2026-05-25T14:55:06.334">
+    <ac:txMkLst xmlns:ac="http://schemas.microsoft.com/office/drawing/2013/main/command">
+      <pc:docMk xmlns:pc="http://schemas.microsoft.com/office/powerpoint/2013/main/command"/>
+      <pc:sldMk xmlns:pc="http://schemas.microsoft.com/office/powerpoint/2013/main/command" cId="3899864669" sldId="273"/>
+      <ac:spMk id="2" creationId="{86118E2B-5EB7-6029-AEBC-3CB415F601B7}"/>
+      <ac:txMk cp="0" len="1">
+        <ac:context len="44" hash="2572100226"/>
+      </ac:txMk>
+    </ac:txMkLst>
+    <p188:pos x="8163531" y="400050"/>
+    <p188:txBody>
+      <a:bodyPr/>
+      <a:lstStyle/>
+      <a:p>
+        <a:r>
+          <a:rPr lang="es-AR"/>
+          <a:t>Grafico torta UDP vs TCP</a:t>
+        </a:r>
+      </a:p>
+    </p188:txBody>
+  </p188:cm>
+</p188:cmLst>
+</file>
+
+<file path=ppt/comments/modernComment_113_28167D32.xml><?xml version="1.0" encoding="utf-8"?>
+<p188:cmLst xmlns:a="http://schemas.openxmlformats.org/drawingml/2006/main" xmlns:r="http://schemas.openxmlformats.org/officeDocument/2006/relationships" xmlns:p188="http://schemas.microsoft.com/office/powerpoint/2018/8/main">
+  <p188:cm id="{41424475-4A06-4E06-AF71-B6B54A6910E8}" authorId="{B464C5B0-C227-F21D-B2F1-7674ACFE52EF}" created="2026-05-25T14:55:06.334">
+    <ac:txMkLst xmlns:ac="http://schemas.microsoft.com/office/drawing/2013/main/command">
+      <pc:docMk xmlns:pc="http://schemas.microsoft.com/office/powerpoint/2013/main/command"/>
+      <pc:sldMk xmlns:pc="http://schemas.microsoft.com/office/powerpoint/2013/main/command" cId="672562482" sldId="275"/>
+      <ac:spMk id="2" creationId="{36048EE2-CB47-6C53-5332-EF5E41721A7B}"/>
+      <ac:txMk cp="0" len="1">
+        <ac:context len="29" hash="708189116"/>
+      </ac:txMk>
+    </ac:txMkLst>
+    <p188:pos x="8163531" y="400050"/>
+    <p188:txBody>
+      <a:bodyPr/>
+      <a:lstStyle/>
+      <a:p>
+        <a:r>
+          <a:rPr lang="es-AR"/>
+          <a:t>Grafico torta UDP vs TCP</a:t>
+        </a:r>
+      </a:p>
+    </p188:txBody>
+  </p188:cm>
+</p188:cmLst>
+</file>
+
+<file path=ppt/comments/modernComment_115_20DFB837.xml><?xml version="1.0" encoding="utf-8"?>
+<p188:cmLst xmlns:a="http://schemas.openxmlformats.org/drawingml/2006/main" xmlns:r="http://schemas.openxmlformats.org/officeDocument/2006/relationships" xmlns:p188="http://schemas.microsoft.com/office/powerpoint/2018/8/main">
+  <p188:cm id="{CD8EB5F5-D302-4C24-87DA-C90F5C533231}" authorId="{B464C5B0-C227-F21D-B2F1-7674ACFE52EF}" created="2026-05-25T14:55:06.334">
+    <ac:txMkLst xmlns:ac="http://schemas.microsoft.com/office/drawing/2013/main/command">
+      <pc:docMk xmlns:pc="http://schemas.microsoft.com/office/powerpoint/2013/main/command"/>
+      <pc:sldMk xmlns:pc="http://schemas.microsoft.com/office/powerpoint/2013/main/command" cId="551532599" sldId="277"/>
+      <ac:spMk id="2" creationId="{3B9ACFB3-3B60-3E46-03CC-D27E188177E4}"/>
+      <ac:txMk cp="0" len="1">
+        <ac:context len="34" hash="781625668"/>
+      </ac:txMk>
+    </ac:txMkLst>
+    <p188:pos x="8163531" y="400050"/>
+    <p188:txBody>
+      <a:bodyPr/>
+      <a:lstStyle/>
+      <a:p>
+        <a:r>
+          <a:rPr lang="es-AR"/>
+          <a:t>Grafico torta UDP vs TCP</a:t>
+        </a:r>
+      </a:p>
+    </p188:txBody>
+  </p188:cm>
+</p188:cmLst>
+</file>
+
 <file path=ppt/slideLayouts/slideLayout1.xml><?xml version="1.0" encoding="utf-8"?>
 <p:sldLayout xmlns:a="http://schemas.openxmlformats.org/drawingml/2006/main" xmlns:r="http://schemas.openxmlformats.org/officeDocument/2006/relationships" xmlns:p="http://schemas.openxmlformats.org/presentationml/2006/main" type="title" preserve="1">
   <p:cSld name="Diapositiva de título">
@@ -306,7 +454,7 @@
           <a:p>
             <a:fld id="{7EA173C4-FDFE-4CC9-A892-42A8535F64AC}" type="datetimeFigureOut">
               <a:rPr lang="es-AR" smtClean="0"/>
-              <a:t>24/5/2026</a:t>
+              <a:t>25/5/2026</a:t>
             </a:fld>
             <a:endParaRPr lang="es-AR"/>
           </a:p>
@@ -604,7 +752,7 @@
           <a:p>
             <a:fld id="{7EA173C4-FDFE-4CC9-A892-42A8535F64AC}" type="datetimeFigureOut">
               <a:rPr lang="es-AR" smtClean="0"/>
-              <a:t>24/5/2026</a:t>
+              <a:t>25/5/2026</a:t>
             </a:fld>
             <a:endParaRPr lang="es-AR"/>
           </a:p>
@@ -796,7 +944,7 @@
           <a:p>
             <a:fld id="{7EA173C4-FDFE-4CC9-A892-42A8535F64AC}" type="datetimeFigureOut">
               <a:rPr lang="es-AR" smtClean="0"/>
-              <a:t>24/5/2026</a:t>
+              <a:t>25/5/2026</a:t>
             </a:fld>
             <a:endParaRPr lang="es-AR"/>
           </a:p>
@@ -1057,7 +1205,7 @@
           <a:p>
             <a:fld id="{7EA173C4-FDFE-4CC9-A892-42A8535F64AC}" type="datetimeFigureOut">
               <a:rPr lang="es-AR" smtClean="0"/>
-              <a:t>24/5/2026</a:t>
+              <a:t>25/5/2026</a:t>
             </a:fld>
             <a:endParaRPr lang="es-AR"/>
           </a:p>
@@ -1481,7 +1629,7 @@
           <a:p>
             <a:fld id="{7EA173C4-FDFE-4CC9-A892-42A8535F64AC}" type="datetimeFigureOut">
               <a:rPr lang="es-AR" smtClean="0"/>
-              <a:t>24/5/2026</a:t>
+              <a:t>25/5/2026</a:t>
             </a:fld>
             <a:endParaRPr lang="es-AR"/>
           </a:p>
@@ -2018,7 +2166,7 @@
           <a:p>
             <a:fld id="{7EA173C4-FDFE-4CC9-A892-42A8535F64AC}" type="datetimeFigureOut">
               <a:rPr lang="es-AR" smtClean="0"/>
-              <a:t>24/5/2026</a:t>
+              <a:t>25/5/2026</a:t>
             </a:fld>
             <a:endParaRPr lang="es-AR"/>
           </a:p>
@@ -2882,7 +3030,7 @@
           <a:p>
             <a:fld id="{7EA173C4-FDFE-4CC9-A892-42A8535F64AC}" type="datetimeFigureOut">
               <a:rPr lang="es-AR" smtClean="0"/>
-              <a:t>24/5/2026</a:t>
+              <a:t>25/5/2026</a:t>
             </a:fld>
             <a:endParaRPr lang="es-AR"/>
           </a:p>
@@ -3052,7 +3200,7 @@
           <a:p>
             <a:fld id="{7EA173C4-FDFE-4CC9-A892-42A8535F64AC}" type="datetimeFigureOut">
               <a:rPr lang="es-AR" smtClean="0"/>
-              <a:t>24/5/2026</a:t>
+              <a:t>25/5/2026</a:t>
             </a:fld>
             <a:endParaRPr lang="es-AR"/>
           </a:p>
@@ -3236,7 +3384,7 @@
           <a:p>
             <a:fld id="{7EA173C4-FDFE-4CC9-A892-42A8535F64AC}" type="datetimeFigureOut">
               <a:rPr lang="es-AR" smtClean="0"/>
-              <a:t>24/5/2026</a:t>
+              <a:t>25/5/2026</a:t>
             </a:fld>
             <a:endParaRPr lang="es-AR"/>
           </a:p>
@@ -3406,7 +3554,7 @@
           <a:p>
             <a:fld id="{7EA173C4-FDFE-4CC9-A892-42A8535F64AC}" type="datetimeFigureOut">
               <a:rPr lang="es-AR" smtClean="0"/>
-              <a:t>24/5/2026</a:t>
+              <a:t>25/5/2026</a:t>
             </a:fld>
             <a:endParaRPr lang="es-AR"/>
           </a:p>
@@ -3650,7 +3798,7 @@
           <a:p>
             <a:fld id="{7EA173C4-FDFE-4CC9-A892-42A8535F64AC}" type="datetimeFigureOut">
               <a:rPr lang="es-AR" smtClean="0"/>
-              <a:t>24/5/2026</a:t>
+              <a:t>25/5/2026</a:t>
             </a:fld>
             <a:endParaRPr lang="es-AR"/>
           </a:p>
@@ -3886,7 +4034,7 @@
           <a:p>
             <a:fld id="{7EA173C4-FDFE-4CC9-A892-42A8535F64AC}" type="datetimeFigureOut">
               <a:rPr lang="es-AR" smtClean="0"/>
-              <a:t>24/5/2026</a:t>
+              <a:t>25/5/2026</a:t>
             </a:fld>
             <a:endParaRPr lang="es-AR"/>
           </a:p>
@@ -4352,7 +4500,7 @@
           <a:p>
             <a:fld id="{7EA173C4-FDFE-4CC9-A892-42A8535F64AC}" type="datetimeFigureOut">
               <a:rPr lang="es-AR" smtClean="0"/>
-              <a:t>24/5/2026</a:t>
+              <a:t>25/5/2026</a:t>
             </a:fld>
             <a:endParaRPr lang="es-AR"/>
           </a:p>
@@ -4470,7 +4618,7 @@
           <a:p>
             <a:fld id="{7EA173C4-FDFE-4CC9-A892-42A8535F64AC}" type="datetimeFigureOut">
               <a:rPr lang="es-AR" smtClean="0"/>
-              <a:t>24/5/2026</a:t>
+              <a:t>25/5/2026</a:t>
             </a:fld>
             <a:endParaRPr lang="es-AR"/>
           </a:p>
@@ -4565,7 +4713,7 @@
           <a:p>
             <a:fld id="{7EA173C4-FDFE-4CC9-A892-42A8535F64AC}" type="datetimeFigureOut">
               <a:rPr lang="es-AR" smtClean="0"/>
-              <a:t>24/5/2026</a:t>
+              <a:t>25/5/2026</a:t>
             </a:fld>
             <a:endParaRPr lang="es-AR"/>
           </a:p>
@@ -4820,7 +4968,7 @@
           <a:p>
             <a:fld id="{7EA173C4-FDFE-4CC9-A892-42A8535F64AC}" type="datetimeFigureOut">
               <a:rPr lang="es-AR" smtClean="0"/>
-              <a:t>24/5/2026</a:t>
+              <a:t>25/5/2026</a:t>
             </a:fld>
             <a:endParaRPr lang="es-AR"/>
           </a:p>
@@ -5120,7 +5268,7 @@
           <a:p>
             <a:fld id="{7EA173C4-FDFE-4CC9-A892-42A8535F64AC}" type="datetimeFigureOut">
               <a:rPr lang="es-AR" smtClean="0"/>
-              <a:t>24/5/2026</a:t>
+              <a:t>25/5/2026</a:t>
             </a:fld>
             <a:endParaRPr lang="es-AR"/>
           </a:p>
@@ -5354,7 +5502,7 @@
           <a:p>
             <a:fld id="{7EA173C4-FDFE-4CC9-A892-42A8535F64AC}" type="datetimeFigureOut">
               <a:rPr lang="es-AR" smtClean="0"/>
-              <a:t>24/5/2026</a:t>
+              <a:t>25/5/2026</a:t>
             </a:fld>
             <a:endParaRPr lang="es-AR"/>
           </a:p>
@@ -6202,6 +6350,2410 @@
 </p:sld>
 </file>
 
+<file path=ppt/slides/slide11.xml><?xml version="1.0" encoding="utf-8"?>
+<p:sld xmlns:a="http://schemas.openxmlformats.org/drawingml/2006/main" xmlns:r="http://schemas.openxmlformats.org/officeDocument/2006/relationships" xmlns:p="http://schemas.openxmlformats.org/presentationml/2006/main">
+  <p:cSld>
+    <p:spTree>
+      <p:nvGrpSpPr>
+        <p:cNvPr id="1" name="">
+          <a:extLst>
+            <a:ext uri="{FF2B5EF4-FFF2-40B4-BE49-F238E27FC236}">
+              <a16:creationId xmlns:a16="http://schemas.microsoft.com/office/drawing/2014/main" id="{A4C548EF-3138-0688-D4F9-87B219FE2ACF}"/>
+            </a:ext>
+          </a:extLst>
+        </p:cNvPr>
+        <p:cNvGrpSpPr/>
+        <p:nvPr/>
+      </p:nvGrpSpPr>
+      <p:grpSpPr>
+        <a:xfrm>
+          <a:off x="0" y="0"/>
+          <a:ext cx="0" cy="0"/>
+          <a:chOff x="0" y="0"/>
+          <a:chExt cx="0" cy="0"/>
+        </a:xfrm>
+      </p:grpSpPr>
+      <p:sp>
+        <p:nvSpPr>
+          <p:cNvPr id="2" name="Título 1">
+            <a:extLst>
+              <a:ext uri="{FF2B5EF4-FFF2-40B4-BE49-F238E27FC236}">
+                <a16:creationId xmlns:a16="http://schemas.microsoft.com/office/drawing/2014/main" id="{36048EE2-CB47-6C53-5332-EF5E41721A7B}"/>
+              </a:ext>
+            </a:extLst>
+          </p:cNvPr>
+          <p:cNvSpPr>
+            <a:spLocks noGrp="1"/>
+          </p:cNvSpPr>
+          <p:nvPr>
+            <p:ph type="title"/>
+          </p:nvPr>
+        </p:nvSpPr>
+        <p:spPr/>
+        <p:txBody>
+          <a:bodyPr/>
+          <a:lstStyle/>
+          <a:p>
+            <a:r>
+              <a:rPr lang="es-AR" dirty="0"/>
+              <a:t>Cantidad de flujos atendidos</a:t>
+            </a:r>
+          </a:p>
+        </p:txBody>
+      </p:sp>
+      <p:sp>
+        <p:nvSpPr>
+          <p:cNvPr id="3" name="Marcador de texto 2">
+            <a:extLst>
+              <a:ext uri="{FF2B5EF4-FFF2-40B4-BE49-F238E27FC236}">
+                <a16:creationId xmlns:a16="http://schemas.microsoft.com/office/drawing/2014/main" id="{7B291D39-09F8-0E29-ACA1-BC8CDC9F9F0E}"/>
+              </a:ext>
+            </a:extLst>
+          </p:cNvPr>
+          <p:cNvSpPr>
+            <a:spLocks noGrp="1"/>
+          </p:cNvSpPr>
+          <p:nvPr>
+            <p:ph type="body" idx="1"/>
+          </p:nvPr>
+        </p:nvSpPr>
+        <p:spPr/>
+        <p:txBody>
+          <a:bodyPr/>
+          <a:lstStyle/>
+          <a:p>
+            <a:r>
+              <a:rPr lang="es-AR" dirty="0"/>
+              <a:t>Escenario I</a:t>
+            </a:r>
+          </a:p>
+        </p:txBody>
+      </p:sp>
+      <p:sp>
+        <p:nvSpPr>
+          <p:cNvPr id="4" name="Marcador de posición de imagen 3">
+            <a:extLst>
+              <a:ext uri="{FF2B5EF4-FFF2-40B4-BE49-F238E27FC236}">
+                <a16:creationId xmlns:a16="http://schemas.microsoft.com/office/drawing/2014/main" id="{7135FC28-1023-3A5A-E20F-EAAE1DA58A1E}"/>
+              </a:ext>
+            </a:extLst>
+          </p:cNvPr>
+          <p:cNvSpPr>
+            <a:spLocks noGrp="1"/>
+          </p:cNvSpPr>
+          <p:nvPr>
+            <p:ph type="pic" idx="15"/>
+          </p:nvPr>
+        </p:nvSpPr>
+        <p:spPr/>
+        <p:txBody>
+          <a:bodyPr/>
+          <a:lstStyle/>
+          <a:p>
+            <a:endParaRPr lang="es-AR"/>
+          </a:p>
+        </p:txBody>
+      </p:sp>
+      <p:sp>
+        <p:nvSpPr>
+          <p:cNvPr id="5" name="Marcador de texto 4">
+            <a:extLst>
+              <a:ext uri="{FF2B5EF4-FFF2-40B4-BE49-F238E27FC236}">
+                <a16:creationId xmlns:a16="http://schemas.microsoft.com/office/drawing/2014/main" id="{E00A01C2-EAEF-8458-CF2F-D9F35A71F1DD}"/>
+              </a:ext>
+            </a:extLst>
+          </p:cNvPr>
+          <p:cNvSpPr>
+            <a:spLocks noGrp="1"/>
+          </p:cNvSpPr>
+          <p:nvPr>
+            <p:ph type="body" sz="half" idx="18"/>
+          </p:nvPr>
+        </p:nvSpPr>
+        <p:spPr/>
+        <p:txBody>
+          <a:bodyPr/>
+          <a:lstStyle/>
+          <a:p>
+            <a:r>
+              <a:rPr lang="es-AR" dirty="0"/>
+              <a:t>[indicador UDP vs TCP]</a:t>
+            </a:r>
+          </a:p>
+        </p:txBody>
+      </p:sp>
+      <p:sp>
+        <p:nvSpPr>
+          <p:cNvPr id="6" name="Marcador de texto 5">
+            <a:extLst>
+              <a:ext uri="{FF2B5EF4-FFF2-40B4-BE49-F238E27FC236}">
+                <a16:creationId xmlns:a16="http://schemas.microsoft.com/office/drawing/2014/main" id="{A6384D07-2C62-4B90-8B63-5BB38F140D00}"/>
+              </a:ext>
+            </a:extLst>
+          </p:cNvPr>
+          <p:cNvSpPr>
+            <a:spLocks noGrp="1"/>
+          </p:cNvSpPr>
+          <p:nvPr>
+            <p:ph type="body" sz="quarter" idx="3"/>
+          </p:nvPr>
+        </p:nvSpPr>
+        <p:spPr/>
+        <p:txBody>
+          <a:bodyPr/>
+          <a:lstStyle/>
+          <a:p>
+            <a:r>
+              <a:rPr lang="es-AR" dirty="0"/>
+              <a:t>Escenario II</a:t>
+            </a:r>
+          </a:p>
+        </p:txBody>
+      </p:sp>
+      <p:sp>
+        <p:nvSpPr>
+          <p:cNvPr id="7" name="Marcador de posición de imagen 6">
+            <a:extLst>
+              <a:ext uri="{FF2B5EF4-FFF2-40B4-BE49-F238E27FC236}">
+                <a16:creationId xmlns:a16="http://schemas.microsoft.com/office/drawing/2014/main" id="{7B2D277E-CB4B-0466-4AFA-46697FF5CA27}"/>
+              </a:ext>
+            </a:extLst>
+          </p:cNvPr>
+          <p:cNvSpPr>
+            <a:spLocks noGrp="1"/>
+          </p:cNvSpPr>
+          <p:nvPr>
+            <p:ph type="pic" idx="21"/>
+          </p:nvPr>
+        </p:nvSpPr>
+        <p:spPr/>
+        <p:txBody>
+          <a:bodyPr/>
+          <a:lstStyle/>
+          <a:p>
+            <a:endParaRPr lang="es-AR"/>
+          </a:p>
+        </p:txBody>
+      </p:sp>
+      <p:sp>
+        <p:nvSpPr>
+          <p:cNvPr id="8" name="Marcador de texto 7">
+            <a:extLst>
+              <a:ext uri="{FF2B5EF4-FFF2-40B4-BE49-F238E27FC236}">
+                <a16:creationId xmlns:a16="http://schemas.microsoft.com/office/drawing/2014/main" id="{08B04E56-1C82-7668-8AC3-7755E221D63E}"/>
+              </a:ext>
+            </a:extLst>
+          </p:cNvPr>
+          <p:cNvSpPr>
+            <a:spLocks noGrp="1"/>
+          </p:cNvSpPr>
+          <p:nvPr>
+            <p:ph type="body" sz="half" idx="19"/>
+          </p:nvPr>
+        </p:nvSpPr>
+        <p:spPr/>
+        <p:txBody>
+          <a:bodyPr/>
+          <a:lstStyle/>
+          <a:p>
+            <a:endParaRPr lang="es-AR"/>
+          </a:p>
+        </p:txBody>
+      </p:sp>
+      <p:sp>
+        <p:nvSpPr>
+          <p:cNvPr id="9" name="Marcador de texto 8">
+            <a:extLst>
+              <a:ext uri="{FF2B5EF4-FFF2-40B4-BE49-F238E27FC236}">
+                <a16:creationId xmlns:a16="http://schemas.microsoft.com/office/drawing/2014/main" id="{1251EECC-BDF1-C5CF-8A68-5CB28F380A26}"/>
+              </a:ext>
+            </a:extLst>
+          </p:cNvPr>
+          <p:cNvSpPr>
+            <a:spLocks noGrp="1"/>
+          </p:cNvSpPr>
+          <p:nvPr>
+            <p:ph type="body" sz="quarter" idx="13"/>
+          </p:nvPr>
+        </p:nvSpPr>
+        <p:spPr/>
+        <p:txBody>
+          <a:bodyPr/>
+          <a:lstStyle/>
+          <a:p>
+            <a:r>
+              <a:rPr lang="es-AR" dirty="0"/>
+              <a:t>Escenario III</a:t>
+            </a:r>
+          </a:p>
+        </p:txBody>
+      </p:sp>
+      <p:sp>
+        <p:nvSpPr>
+          <p:cNvPr id="10" name="Marcador de posición de imagen 9">
+            <a:extLst>
+              <a:ext uri="{FF2B5EF4-FFF2-40B4-BE49-F238E27FC236}">
+                <a16:creationId xmlns:a16="http://schemas.microsoft.com/office/drawing/2014/main" id="{4F60B096-4EDA-35FC-90D3-6D48B0315174}"/>
+              </a:ext>
+            </a:extLst>
+          </p:cNvPr>
+          <p:cNvSpPr>
+            <a:spLocks noGrp="1"/>
+          </p:cNvSpPr>
+          <p:nvPr>
+            <p:ph type="pic" idx="22"/>
+          </p:nvPr>
+        </p:nvSpPr>
+        <p:spPr/>
+        <p:txBody>
+          <a:bodyPr/>
+          <a:lstStyle/>
+          <a:p>
+            <a:endParaRPr lang="es-AR"/>
+          </a:p>
+        </p:txBody>
+      </p:sp>
+      <p:sp>
+        <p:nvSpPr>
+          <p:cNvPr id="11" name="Marcador de texto 10">
+            <a:extLst>
+              <a:ext uri="{FF2B5EF4-FFF2-40B4-BE49-F238E27FC236}">
+                <a16:creationId xmlns:a16="http://schemas.microsoft.com/office/drawing/2014/main" id="{3FA57C59-EC7E-599B-B658-EFA635C08CC7}"/>
+              </a:ext>
+            </a:extLst>
+          </p:cNvPr>
+          <p:cNvSpPr>
+            <a:spLocks noGrp="1"/>
+          </p:cNvSpPr>
+          <p:nvPr>
+            <p:ph type="body" sz="half" idx="20"/>
+          </p:nvPr>
+        </p:nvSpPr>
+        <p:spPr/>
+        <p:txBody>
+          <a:bodyPr/>
+          <a:lstStyle/>
+          <a:p>
+            <a:endParaRPr lang="es-AR"/>
+          </a:p>
+        </p:txBody>
+      </p:sp>
+    </p:spTree>
+    <p:extLst>
+      <p:ext uri="{BB962C8B-B14F-4D97-AF65-F5344CB8AC3E}">
+        <p14:creationId xmlns:p14="http://schemas.microsoft.com/office/powerpoint/2010/main" val="672562482"/>
+      </p:ext>
+    </p:extLst>
+  </p:cSld>
+  <p:clrMapOvr>
+    <a:masterClrMapping/>
+  </p:clrMapOvr>
+  <p:extLst>
+    <p:ext uri="{6950BFC3-D8DA-4A85-94F7-54DA5524770B}">
+      <p188:commentRel xmlns:p188="http://schemas.microsoft.com/office/powerpoint/2018/8/main" r:id="rId2"/>
+    </p:ext>
+  </p:extLst>
+</p:sld>
+</file>
+
+<file path=ppt/slides/slide12.xml><?xml version="1.0" encoding="utf-8"?>
+<p:sld xmlns:a="http://schemas.openxmlformats.org/drawingml/2006/main" xmlns:r="http://schemas.openxmlformats.org/officeDocument/2006/relationships" xmlns:p="http://schemas.openxmlformats.org/presentationml/2006/main">
+  <p:cSld>
+    <p:spTree>
+      <p:nvGrpSpPr>
+        <p:cNvPr id="1" name="">
+          <a:extLst>
+            <a:ext uri="{FF2B5EF4-FFF2-40B4-BE49-F238E27FC236}">
+              <a16:creationId xmlns:a16="http://schemas.microsoft.com/office/drawing/2014/main" id="{72095C30-5A4D-9682-497B-3323EE571AF0}"/>
+            </a:ext>
+          </a:extLst>
+        </p:cNvPr>
+        <p:cNvGrpSpPr/>
+        <p:nvPr/>
+      </p:nvGrpSpPr>
+      <p:grpSpPr>
+        <a:xfrm>
+          <a:off x="0" y="0"/>
+          <a:ext cx="0" cy="0"/>
+          <a:chOff x="0" y="0"/>
+          <a:chExt cx="0" cy="0"/>
+        </a:xfrm>
+      </p:grpSpPr>
+      <p:sp>
+        <p:nvSpPr>
+          <p:cNvPr id="2" name="Título 1">
+            <a:extLst>
+              <a:ext uri="{FF2B5EF4-FFF2-40B4-BE49-F238E27FC236}">
+                <a16:creationId xmlns:a16="http://schemas.microsoft.com/office/drawing/2014/main" id="{99905A1A-F5C6-EB92-34FA-34D5F8D83957}"/>
+              </a:ext>
+            </a:extLst>
+          </p:cNvPr>
+          <p:cNvSpPr>
+            <a:spLocks noGrp="1"/>
+          </p:cNvSpPr>
+          <p:nvPr>
+            <p:ph type="title"/>
+          </p:nvPr>
+        </p:nvSpPr>
+        <p:spPr/>
+        <p:txBody>
+          <a:bodyPr/>
+          <a:lstStyle/>
+          <a:p>
+            <a:r>
+              <a:rPr lang="es-AR" dirty="0"/>
+              <a:t>Cantidad de flujos atendidos</a:t>
+            </a:r>
+          </a:p>
+        </p:txBody>
+      </p:sp>
+      <p:sp>
+        <p:nvSpPr>
+          <p:cNvPr id="3" name="Marcador de texto 2">
+            <a:extLst>
+              <a:ext uri="{FF2B5EF4-FFF2-40B4-BE49-F238E27FC236}">
+                <a16:creationId xmlns:a16="http://schemas.microsoft.com/office/drawing/2014/main" id="{D41E6E5F-E731-E3C5-9700-0A253DF2B5FE}"/>
+              </a:ext>
+            </a:extLst>
+          </p:cNvPr>
+          <p:cNvSpPr>
+            <a:spLocks noGrp="1"/>
+          </p:cNvSpPr>
+          <p:nvPr>
+            <p:ph type="body" idx="1"/>
+          </p:nvPr>
+        </p:nvSpPr>
+        <p:spPr/>
+        <p:txBody>
+          <a:bodyPr/>
+          <a:lstStyle/>
+          <a:p>
+            <a:r>
+              <a:rPr lang="es-AR" dirty="0"/>
+              <a:t>Escenario IV</a:t>
+            </a:r>
+          </a:p>
+        </p:txBody>
+      </p:sp>
+      <p:sp>
+        <p:nvSpPr>
+          <p:cNvPr id="4" name="Marcador de posición de imagen 3">
+            <a:extLst>
+              <a:ext uri="{FF2B5EF4-FFF2-40B4-BE49-F238E27FC236}">
+                <a16:creationId xmlns:a16="http://schemas.microsoft.com/office/drawing/2014/main" id="{79E0D2F4-1C53-0521-540B-9E2809A1ECBE}"/>
+              </a:ext>
+            </a:extLst>
+          </p:cNvPr>
+          <p:cNvSpPr>
+            <a:spLocks noGrp="1"/>
+          </p:cNvSpPr>
+          <p:nvPr>
+            <p:ph type="pic" idx="15"/>
+          </p:nvPr>
+        </p:nvSpPr>
+        <p:spPr/>
+        <p:txBody>
+          <a:bodyPr/>
+          <a:lstStyle/>
+          <a:p>
+            <a:endParaRPr lang="es-AR"/>
+          </a:p>
+        </p:txBody>
+      </p:sp>
+      <p:sp>
+        <p:nvSpPr>
+          <p:cNvPr id="5" name="Marcador de texto 4">
+            <a:extLst>
+              <a:ext uri="{FF2B5EF4-FFF2-40B4-BE49-F238E27FC236}">
+                <a16:creationId xmlns:a16="http://schemas.microsoft.com/office/drawing/2014/main" id="{A1C33536-9DA3-D178-FFC1-272B07A712E4}"/>
+              </a:ext>
+            </a:extLst>
+          </p:cNvPr>
+          <p:cNvSpPr>
+            <a:spLocks noGrp="1"/>
+          </p:cNvSpPr>
+          <p:nvPr>
+            <p:ph type="body" sz="half" idx="18"/>
+          </p:nvPr>
+        </p:nvSpPr>
+        <p:spPr/>
+        <p:txBody>
+          <a:bodyPr/>
+          <a:lstStyle/>
+          <a:p>
+            <a:endParaRPr lang="es-AR"/>
+          </a:p>
+        </p:txBody>
+      </p:sp>
+      <p:sp>
+        <p:nvSpPr>
+          <p:cNvPr id="6" name="Marcador de texto 5">
+            <a:extLst>
+              <a:ext uri="{FF2B5EF4-FFF2-40B4-BE49-F238E27FC236}">
+                <a16:creationId xmlns:a16="http://schemas.microsoft.com/office/drawing/2014/main" id="{D674C1BF-A30D-DE0B-AAFD-20E96B81A3E4}"/>
+              </a:ext>
+            </a:extLst>
+          </p:cNvPr>
+          <p:cNvSpPr>
+            <a:spLocks noGrp="1"/>
+          </p:cNvSpPr>
+          <p:nvPr>
+            <p:ph type="body" sz="quarter" idx="3"/>
+          </p:nvPr>
+        </p:nvSpPr>
+        <p:spPr/>
+        <p:txBody>
+          <a:bodyPr/>
+          <a:lstStyle/>
+          <a:p>
+            <a:r>
+              <a:rPr lang="es-AR" dirty="0"/>
+              <a:t>Escenario V</a:t>
+            </a:r>
+          </a:p>
+        </p:txBody>
+      </p:sp>
+      <p:sp>
+        <p:nvSpPr>
+          <p:cNvPr id="7" name="Marcador de posición de imagen 6">
+            <a:extLst>
+              <a:ext uri="{FF2B5EF4-FFF2-40B4-BE49-F238E27FC236}">
+                <a16:creationId xmlns:a16="http://schemas.microsoft.com/office/drawing/2014/main" id="{B15AD8A6-8608-15BB-19BA-CC5DEC55165A}"/>
+              </a:ext>
+            </a:extLst>
+          </p:cNvPr>
+          <p:cNvSpPr>
+            <a:spLocks noGrp="1"/>
+          </p:cNvSpPr>
+          <p:nvPr>
+            <p:ph type="pic" idx="21"/>
+          </p:nvPr>
+        </p:nvSpPr>
+        <p:spPr/>
+        <p:txBody>
+          <a:bodyPr/>
+          <a:lstStyle/>
+          <a:p>
+            <a:endParaRPr lang="es-AR"/>
+          </a:p>
+        </p:txBody>
+      </p:sp>
+      <p:sp>
+        <p:nvSpPr>
+          <p:cNvPr id="8" name="Marcador de texto 7">
+            <a:extLst>
+              <a:ext uri="{FF2B5EF4-FFF2-40B4-BE49-F238E27FC236}">
+                <a16:creationId xmlns:a16="http://schemas.microsoft.com/office/drawing/2014/main" id="{A50F6C4D-0271-3156-4C2D-413B6BBC4BA4}"/>
+              </a:ext>
+            </a:extLst>
+          </p:cNvPr>
+          <p:cNvSpPr>
+            <a:spLocks noGrp="1"/>
+          </p:cNvSpPr>
+          <p:nvPr>
+            <p:ph type="body" sz="half" idx="19"/>
+          </p:nvPr>
+        </p:nvSpPr>
+        <p:spPr/>
+        <p:txBody>
+          <a:bodyPr/>
+          <a:lstStyle/>
+          <a:p>
+            <a:endParaRPr lang="es-AR" dirty="0"/>
+          </a:p>
+        </p:txBody>
+      </p:sp>
+    </p:spTree>
+    <p:extLst>
+      <p:ext uri="{BB962C8B-B14F-4D97-AF65-F5344CB8AC3E}">
+        <p14:creationId xmlns:p14="http://schemas.microsoft.com/office/powerpoint/2010/main" val="4051844680"/>
+      </p:ext>
+    </p:extLst>
+  </p:cSld>
+  <p:clrMapOvr>
+    <a:masterClrMapping/>
+  </p:clrMapOvr>
+</p:sld>
+</file>
+
+<file path=ppt/slides/slide13.xml><?xml version="1.0" encoding="utf-8"?>
+<p:sld xmlns:a="http://schemas.openxmlformats.org/drawingml/2006/main" xmlns:r="http://schemas.openxmlformats.org/officeDocument/2006/relationships" xmlns:p="http://schemas.openxmlformats.org/presentationml/2006/main">
+  <p:cSld>
+    <p:spTree>
+      <p:nvGrpSpPr>
+        <p:cNvPr id="1" name=""/>
+        <p:cNvGrpSpPr/>
+        <p:nvPr/>
+      </p:nvGrpSpPr>
+      <p:grpSpPr>
+        <a:xfrm>
+          <a:off x="0" y="0"/>
+          <a:ext cx="0" cy="0"/>
+          <a:chOff x="0" y="0"/>
+          <a:chExt cx="0" cy="0"/>
+        </a:xfrm>
+      </p:grpSpPr>
+      <p:sp>
+        <p:nvSpPr>
+          <p:cNvPr id="2" name="Título 1">
+            <a:extLst>
+              <a:ext uri="{FF2B5EF4-FFF2-40B4-BE49-F238E27FC236}">
+                <a16:creationId xmlns:a16="http://schemas.microsoft.com/office/drawing/2014/main" id="{79B7201B-781D-B10D-7090-2248D1CA71B8}"/>
+              </a:ext>
+            </a:extLst>
+          </p:cNvPr>
+          <p:cNvSpPr>
+            <a:spLocks noGrp="1"/>
+          </p:cNvSpPr>
+          <p:nvPr>
+            <p:ph type="title"/>
+          </p:nvPr>
+        </p:nvSpPr>
+        <p:spPr/>
+        <p:txBody>
+          <a:bodyPr/>
+          <a:lstStyle/>
+          <a:p>
+            <a:r>
+              <a:rPr lang="es-AR" dirty="0"/>
+              <a:t>Promedio de espera en cola</a:t>
+            </a:r>
+          </a:p>
+        </p:txBody>
+      </p:sp>
+      <p:sp>
+        <p:nvSpPr>
+          <p:cNvPr id="3" name="Marcador de texto 2">
+            <a:extLst>
+              <a:ext uri="{FF2B5EF4-FFF2-40B4-BE49-F238E27FC236}">
+                <a16:creationId xmlns:a16="http://schemas.microsoft.com/office/drawing/2014/main" id="{F6BE4CFC-36C8-2790-B963-1326B23AA4AA}"/>
+              </a:ext>
+            </a:extLst>
+          </p:cNvPr>
+          <p:cNvSpPr>
+            <a:spLocks noGrp="1"/>
+          </p:cNvSpPr>
+          <p:nvPr>
+            <p:ph type="body" idx="1"/>
+          </p:nvPr>
+        </p:nvSpPr>
+        <p:spPr/>
+        <p:txBody>
+          <a:bodyPr/>
+          <a:lstStyle/>
+          <a:p>
+            <a:r>
+              <a:rPr lang="es-AR" dirty="0"/>
+              <a:t>Escenario I</a:t>
+            </a:r>
+          </a:p>
+        </p:txBody>
+      </p:sp>
+      <p:sp>
+        <p:nvSpPr>
+          <p:cNvPr id="4" name="Marcador de posición de imagen 3">
+            <a:extLst>
+              <a:ext uri="{FF2B5EF4-FFF2-40B4-BE49-F238E27FC236}">
+                <a16:creationId xmlns:a16="http://schemas.microsoft.com/office/drawing/2014/main" id="{672B81C5-DA73-1BD4-F4F1-76BE406D0A22}"/>
+              </a:ext>
+            </a:extLst>
+          </p:cNvPr>
+          <p:cNvSpPr>
+            <a:spLocks noGrp="1"/>
+          </p:cNvSpPr>
+          <p:nvPr>
+            <p:ph type="pic" idx="15"/>
+          </p:nvPr>
+        </p:nvSpPr>
+        <p:spPr/>
+        <p:txBody>
+          <a:bodyPr/>
+          <a:lstStyle/>
+          <a:p>
+            <a:endParaRPr lang="es-AR"/>
+          </a:p>
+        </p:txBody>
+      </p:sp>
+      <p:sp>
+        <p:nvSpPr>
+          <p:cNvPr id="5" name="Marcador de texto 4">
+            <a:extLst>
+              <a:ext uri="{FF2B5EF4-FFF2-40B4-BE49-F238E27FC236}">
+                <a16:creationId xmlns:a16="http://schemas.microsoft.com/office/drawing/2014/main" id="{D43CE296-1D6C-BAA7-A5A4-1D091B405629}"/>
+              </a:ext>
+            </a:extLst>
+          </p:cNvPr>
+          <p:cNvSpPr>
+            <a:spLocks noGrp="1"/>
+          </p:cNvSpPr>
+          <p:nvPr>
+            <p:ph type="body" sz="half" idx="18"/>
+          </p:nvPr>
+        </p:nvSpPr>
+        <p:spPr/>
+        <p:txBody>
+          <a:bodyPr/>
+          <a:lstStyle/>
+          <a:p>
+            <a:r>
+              <a:rPr lang="es-AR" dirty="0"/>
+              <a:t>[histograma UDP vs TCP]</a:t>
+            </a:r>
+          </a:p>
+        </p:txBody>
+      </p:sp>
+      <p:sp>
+        <p:nvSpPr>
+          <p:cNvPr id="6" name="Marcador de texto 5">
+            <a:extLst>
+              <a:ext uri="{FF2B5EF4-FFF2-40B4-BE49-F238E27FC236}">
+                <a16:creationId xmlns:a16="http://schemas.microsoft.com/office/drawing/2014/main" id="{34CBC425-5D2C-844F-B6CB-91C8A85FDE2F}"/>
+              </a:ext>
+            </a:extLst>
+          </p:cNvPr>
+          <p:cNvSpPr>
+            <a:spLocks noGrp="1"/>
+          </p:cNvSpPr>
+          <p:nvPr>
+            <p:ph type="body" sz="quarter" idx="3"/>
+          </p:nvPr>
+        </p:nvSpPr>
+        <p:spPr/>
+        <p:txBody>
+          <a:bodyPr/>
+          <a:lstStyle/>
+          <a:p>
+            <a:r>
+              <a:rPr lang="es-AR" dirty="0"/>
+              <a:t>Escenario II</a:t>
+            </a:r>
+          </a:p>
+        </p:txBody>
+      </p:sp>
+      <p:sp>
+        <p:nvSpPr>
+          <p:cNvPr id="7" name="Marcador de posición de imagen 6">
+            <a:extLst>
+              <a:ext uri="{FF2B5EF4-FFF2-40B4-BE49-F238E27FC236}">
+                <a16:creationId xmlns:a16="http://schemas.microsoft.com/office/drawing/2014/main" id="{8C61CE6D-F7EE-E394-FB35-B509434238D1}"/>
+              </a:ext>
+            </a:extLst>
+          </p:cNvPr>
+          <p:cNvSpPr>
+            <a:spLocks noGrp="1"/>
+          </p:cNvSpPr>
+          <p:nvPr>
+            <p:ph type="pic" idx="21"/>
+          </p:nvPr>
+        </p:nvSpPr>
+        <p:spPr/>
+        <p:txBody>
+          <a:bodyPr/>
+          <a:lstStyle/>
+          <a:p>
+            <a:endParaRPr lang="es-AR"/>
+          </a:p>
+        </p:txBody>
+      </p:sp>
+      <p:sp>
+        <p:nvSpPr>
+          <p:cNvPr id="8" name="Marcador de texto 7">
+            <a:extLst>
+              <a:ext uri="{FF2B5EF4-FFF2-40B4-BE49-F238E27FC236}">
+                <a16:creationId xmlns:a16="http://schemas.microsoft.com/office/drawing/2014/main" id="{0550AB4C-6D97-F2D2-874A-C27126B7EE37}"/>
+              </a:ext>
+            </a:extLst>
+          </p:cNvPr>
+          <p:cNvSpPr>
+            <a:spLocks noGrp="1"/>
+          </p:cNvSpPr>
+          <p:nvPr>
+            <p:ph type="body" sz="half" idx="19"/>
+          </p:nvPr>
+        </p:nvSpPr>
+        <p:spPr/>
+        <p:txBody>
+          <a:bodyPr/>
+          <a:lstStyle/>
+          <a:p>
+            <a:endParaRPr lang="es-AR"/>
+          </a:p>
+        </p:txBody>
+      </p:sp>
+      <p:sp>
+        <p:nvSpPr>
+          <p:cNvPr id="9" name="Marcador de texto 8">
+            <a:extLst>
+              <a:ext uri="{FF2B5EF4-FFF2-40B4-BE49-F238E27FC236}">
+                <a16:creationId xmlns:a16="http://schemas.microsoft.com/office/drawing/2014/main" id="{ED4CD14C-B393-4B60-AC50-956B3146F238}"/>
+              </a:ext>
+            </a:extLst>
+          </p:cNvPr>
+          <p:cNvSpPr>
+            <a:spLocks noGrp="1"/>
+          </p:cNvSpPr>
+          <p:nvPr>
+            <p:ph type="body" sz="quarter" idx="13"/>
+          </p:nvPr>
+        </p:nvSpPr>
+        <p:spPr/>
+        <p:txBody>
+          <a:bodyPr/>
+          <a:lstStyle/>
+          <a:p>
+            <a:r>
+              <a:rPr lang="es-AR" dirty="0"/>
+              <a:t>Escenario III</a:t>
+            </a:r>
+          </a:p>
+        </p:txBody>
+      </p:sp>
+      <p:sp>
+        <p:nvSpPr>
+          <p:cNvPr id="10" name="Marcador de posición de imagen 9">
+            <a:extLst>
+              <a:ext uri="{FF2B5EF4-FFF2-40B4-BE49-F238E27FC236}">
+                <a16:creationId xmlns:a16="http://schemas.microsoft.com/office/drawing/2014/main" id="{4DAD977C-6963-093E-CFBE-EFBA64BAC7F5}"/>
+              </a:ext>
+            </a:extLst>
+          </p:cNvPr>
+          <p:cNvSpPr>
+            <a:spLocks noGrp="1"/>
+          </p:cNvSpPr>
+          <p:nvPr>
+            <p:ph type="pic" idx="22"/>
+          </p:nvPr>
+        </p:nvSpPr>
+        <p:spPr/>
+        <p:txBody>
+          <a:bodyPr/>
+          <a:lstStyle/>
+          <a:p>
+            <a:endParaRPr lang="es-AR"/>
+          </a:p>
+        </p:txBody>
+      </p:sp>
+      <p:sp>
+        <p:nvSpPr>
+          <p:cNvPr id="11" name="Marcador de texto 10">
+            <a:extLst>
+              <a:ext uri="{FF2B5EF4-FFF2-40B4-BE49-F238E27FC236}">
+                <a16:creationId xmlns:a16="http://schemas.microsoft.com/office/drawing/2014/main" id="{E921376F-5772-C9BF-8D0A-23E769CDCC05}"/>
+              </a:ext>
+            </a:extLst>
+          </p:cNvPr>
+          <p:cNvSpPr>
+            <a:spLocks noGrp="1"/>
+          </p:cNvSpPr>
+          <p:nvPr>
+            <p:ph type="body" sz="half" idx="20"/>
+          </p:nvPr>
+        </p:nvSpPr>
+        <p:spPr/>
+        <p:txBody>
+          <a:bodyPr/>
+          <a:lstStyle/>
+          <a:p>
+            <a:endParaRPr lang="es-AR"/>
+          </a:p>
+        </p:txBody>
+      </p:sp>
+    </p:spTree>
+    <p:extLst>
+      <p:ext uri="{BB962C8B-B14F-4D97-AF65-F5344CB8AC3E}">
+        <p14:creationId xmlns:p14="http://schemas.microsoft.com/office/powerpoint/2010/main" val="3999833237"/>
+      </p:ext>
+    </p:extLst>
+  </p:cSld>
+  <p:clrMapOvr>
+    <a:masterClrMapping/>
+  </p:clrMapOvr>
+  <p:extLst>
+    <p:ext uri="{6950BFC3-D8DA-4A85-94F7-54DA5524770B}">
+      <p188:commentRel xmlns:p188="http://schemas.microsoft.com/office/powerpoint/2018/8/main" r:id="rId2"/>
+    </p:ext>
+  </p:extLst>
+</p:sld>
+</file>
+
+<file path=ppt/slides/slide14.xml><?xml version="1.0" encoding="utf-8"?>
+<p:sld xmlns:a="http://schemas.openxmlformats.org/drawingml/2006/main" xmlns:r="http://schemas.openxmlformats.org/officeDocument/2006/relationships" xmlns:p="http://schemas.openxmlformats.org/presentationml/2006/main">
+  <p:cSld>
+    <p:spTree>
+      <p:nvGrpSpPr>
+        <p:cNvPr id="1" name="">
+          <a:extLst>
+            <a:ext uri="{FF2B5EF4-FFF2-40B4-BE49-F238E27FC236}">
+              <a16:creationId xmlns:a16="http://schemas.microsoft.com/office/drawing/2014/main" id="{ED688674-51FC-DC67-AE55-D2C30430E54C}"/>
+            </a:ext>
+          </a:extLst>
+        </p:cNvPr>
+        <p:cNvGrpSpPr/>
+        <p:nvPr/>
+      </p:nvGrpSpPr>
+      <p:grpSpPr>
+        <a:xfrm>
+          <a:off x="0" y="0"/>
+          <a:ext cx="0" cy="0"/>
+          <a:chOff x="0" y="0"/>
+          <a:chExt cx="0" cy="0"/>
+        </a:xfrm>
+      </p:grpSpPr>
+      <p:sp>
+        <p:nvSpPr>
+          <p:cNvPr id="2" name="Título 1">
+            <a:extLst>
+              <a:ext uri="{FF2B5EF4-FFF2-40B4-BE49-F238E27FC236}">
+                <a16:creationId xmlns:a16="http://schemas.microsoft.com/office/drawing/2014/main" id="{5842C069-B9EF-0C31-6E61-156226795FF9}"/>
+              </a:ext>
+            </a:extLst>
+          </p:cNvPr>
+          <p:cNvSpPr>
+            <a:spLocks noGrp="1"/>
+          </p:cNvSpPr>
+          <p:nvPr>
+            <p:ph type="title"/>
+          </p:nvPr>
+        </p:nvSpPr>
+        <p:spPr/>
+        <p:txBody>
+          <a:bodyPr/>
+          <a:lstStyle/>
+          <a:p>
+            <a:r>
+              <a:rPr lang="es-AR" dirty="0"/>
+              <a:t>Promedio de espera en cola</a:t>
+            </a:r>
+          </a:p>
+        </p:txBody>
+      </p:sp>
+      <p:sp>
+        <p:nvSpPr>
+          <p:cNvPr id="3" name="Marcador de texto 2">
+            <a:extLst>
+              <a:ext uri="{FF2B5EF4-FFF2-40B4-BE49-F238E27FC236}">
+                <a16:creationId xmlns:a16="http://schemas.microsoft.com/office/drawing/2014/main" id="{2C8CFFBF-DAFB-B7AB-59DB-9136034C119F}"/>
+              </a:ext>
+            </a:extLst>
+          </p:cNvPr>
+          <p:cNvSpPr>
+            <a:spLocks noGrp="1"/>
+          </p:cNvSpPr>
+          <p:nvPr>
+            <p:ph type="body" idx="1"/>
+          </p:nvPr>
+        </p:nvSpPr>
+        <p:spPr/>
+        <p:txBody>
+          <a:bodyPr/>
+          <a:lstStyle/>
+          <a:p>
+            <a:r>
+              <a:rPr lang="es-AR" dirty="0"/>
+              <a:t>Escenario IV</a:t>
+            </a:r>
+          </a:p>
+        </p:txBody>
+      </p:sp>
+      <p:sp>
+        <p:nvSpPr>
+          <p:cNvPr id="4" name="Marcador de posición de imagen 3">
+            <a:extLst>
+              <a:ext uri="{FF2B5EF4-FFF2-40B4-BE49-F238E27FC236}">
+                <a16:creationId xmlns:a16="http://schemas.microsoft.com/office/drawing/2014/main" id="{2769B276-4902-6F73-2577-58AE8C8BDB38}"/>
+              </a:ext>
+            </a:extLst>
+          </p:cNvPr>
+          <p:cNvSpPr>
+            <a:spLocks noGrp="1"/>
+          </p:cNvSpPr>
+          <p:nvPr>
+            <p:ph type="pic" idx="15"/>
+          </p:nvPr>
+        </p:nvSpPr>
+        <p:spPr/>
+        <p:txBody>
+          <a:bodyPr/>
+          <a:lstStyle/>
+          <a:p>
+            <a:endParaRPr lang="es-AR"/>
+          </a:p>
+        </p:txBody>
+      </p:sp>
+      <p:sp>
+        <p:nvSpPr>
+          <p:cNvPr id="5" name="Marcador de texto 4">
+            <a:extLst>
+              <a:ext uri="{FF2B5EF4-FFF2-40B4-BE49-F238E27FC236}">
+                <a16:creationId xmlns:a16="http://schemas.microsoft.com/office/drawing/2014/main" id="{824B2EDA-4F9D-2105-3A73-F72AEFB0C022}"/>
+              </a:ext>
+            </a:extLst>
+          </p:cNvPr>
+          <p:cNvSpPr>
+            <a:spLocks noGrp="1"/>
+          </p:cNvSpPr>
+          <p:nvPr>
+            <p:ph type="body" sz="half" idx="18"/>
+          </p:nvPr>
+        </p:nvSpPr>
+        <p:spPr/>
+        <p:txBody>
+          <a:bodyPr/>
+          <a:lstStyle/>
+          <a:p>
+            <a:endParaRPr lang="es-AR"/>
+          </a:p>
+        </p:txBody>
+      </p:sp>
+      <p:sp>
+        <p:nvSpPr>
+          <p:cNvPr id="6" name="Marcador de texto 5">
+            <a:extLst>
+              <a:ext uri="{FF2B5EF4-FFF2-40B4-BE49-F238E27FC236}">
+                <a16:creationId xmlns:a16="http://schemas.microsoft.com/office/drawing/2014/main" id="{02A5C348-DDBB-8FCA-F27A-0A8AFA65DEEA}"/>
+              </a:ext>
+            </a:extLst>
+          </p:cNvPr>
+          <p:cNvSpPr>
+            <a:spLocks noGrp="1"/>
+          </p:cNvSpPr>
+          <p:nvPr>
+            <p:ph type="body" sz="quarter" idx="3"/>
+          </p:nvPr>
+        </p:nvSpPr>
+        <p:spPr/>
+        <p:txBody>
+          <a:bodyPr/>
+          <a:lstStyle/>
+          <a:p>
+            <a:r>
+              <a:rPr lang="es-AR" dirty="0"/>
+              <a:t>Escenario V</a:t>
+            </a:r>
+          </a:p>
+        </p:txBody>
+      </p:sp>
+      <p:sp>
+        <p:nvSpPr>
+          <p:cNvPr id="7" name="Marcador de posición de imagen 6">
+            <a:extLst>
+              <a:ext uri="{FF2B5EF4-FFF2-40B4-BE49-F238E27FC236}">
+                <a16:creationId xmlns:a16="http://schemas.microsoft.com/office/drawing/2014/main" id="{420355DB-E22D-36C9-CA30-7A0B9A816356}"/>
+              </a:ext>
+            </a:extLst>
+          </p:cNvPr>
+          <p:cNvSpPr>
+            <a:spLocks noGrp="1"/>
+          </p:cNvSpPr>
+          <p:nvPr>
+            <p:ph type="pic" idx="21"/>
+          </p:nvPr>
+        </p:nvSpPr>
+        <p:spPr/>
+        <p:txBody>
+          <a:bodyPr/>
+          <a:lstStyle/>
+          <a:p>
+            <a:endParaRPr lang="es-AR"/>
+          </a:p>
+        </p:txBody>
+      </p:sp>
+      <p:sp>
+        <p:nvSpPr>
+          <p:cNvPr id="8" name="Marcador de texto 7">
+            <a:extLst>
+              <a:ext uri="{FF2B5EF4-FFF2-40B4-BE49-F238E27FC236}">
+                <a16:creationId xmlns:a16="http://schemas.microsoft.com/office/drawing/2014/main" id="{18EF1B0F-A355-663B-1448-1CE4B3EDE197}"/>
+              </a:ext>
+            </a:extLst>
+          </p:cNvPr>
+          <p:cNvSpPr>
+            <a:spLocks noGrp="1"/>
+          </p:cNvSpPr>
+          <p:nvPr>
+            <p:ph type="body" sz="half" idx="19"/>
+          </p:nvPr>
+        </p:nvSpPr>
+        <p:spPr/>
+        <p:txBody>
+          <a:bodyPr/>
+          <a:lstStyle/>
+          <a:p>
+            <a:endParaRPr lang="es-AR" dirty="0"/>
+          </a:p>
+        </p:txBody>
+      </p:sp>
+    </p:spTree>
+    <p:extLst>
+      <p:ext uri="{BB962C8B-B14F-4D97-AF65-F5344CB8AC3E}">
+        <p14:creationId xmlns:p14="http://schemas.microsoft.com/office/powerpoint/2010/main" val="1152186622"/>
+      </p:ext>
+    </p:extLst>
+  </p:cSld>
+  <p:clrMapOvr>
+    <a:masterClrMapping/>
+  </p:clrMapOvr>
+</p:sld>
+</file>
+
+<file path=ppt/slides/slide15.xml><?xml version="1.0" encoding="utf-8"?>
+<p:sld xmlns:a="http://schemas.openxmlformats.org/drawingml/2006/main" xmlns:r="http://schemas.openxmlformats.org/officeDocument/2006/relationships" xmlns:p="http://schemas.openxmlformats.org/presentationml/2006/main">
+  <p:cSld>
+    <p:spTree>
+      <p:nvGrpSpPr>
+        <p:cNvPr id="1" name="">
+          <a:extLst>
+            <a:ext uri="{FF2B5EF4-FFF2-40B4-BE49-F238E27FC236}">
+              <a16:creationId xmlns:a16="http://schemas.microsoft.com/office/drawing/2014/main" id="{6BE2FCDA-3842-7FA0-3F7A-84642C53BA5A}"/>
+            </a:ext>
+          </a:extLst>
+        </p:cNvPr>
+        <p:cNvGrpSpPr/>
+        <p:nvPr/>
+      </p:nvGrpSpPr>
+      <p:grpSpPr>
+        <a:xfrm>
+          <a:off x="0" y="0"/>
+          <a:ext cx="0" cy="0"/>
+          <a:chOff x="0" y="0"/>
+          <a:chExt cx="0" cy="0"/>
+        </a:xfrm>
+      </p:grpSpPr>
+      <p:sp>
+        <p:nvSpPr>
+          <p:cNvPr id="2" name="Título 1">
+            <a:extLst>
+              <a:ext uri="{FF2B5EF4-FFF2-40B4-BE49-F238E27FC236}">
+                <a16:creationId xmlns:a16="http://schemas.microsoft.com/office/drawing/2014/main" id="{74FF1088-6BD5-58E8-0C5D-5288E3148F07}"/>
+              </a:ext>
+            </a:extLst>
+          </p:cNvPr>
+          <p:cNvSpPr>
+            <a:spLocks noGrp="1"/>
+          </p:cNvSpPr>
+          <p:nvPr>
+            <p:ph type="title"/>
+          </p:nvPr>
+        </p:nvSpPr>
+        <p:spPr/>
+        <p:txBody>
+          <a:bodyPr/>
+          <a:lstStyle/>
+          <a:p>
+            <a:r>
+              <a:rPr lang="es-AR" dirty="0"/>
+              <a:t>Porcentaje tiempo ocioso servidores Clase A</a:t>
+            </a:r>
+          </a:p>
+        </p:txBody>
+      </p:sp>
+      <p:sp>
+        <p:nvSpPr>
+          <p:cNvPr id="3" name="Marcador de texto 2">
+            <a:extLst>
+              <a:ext uri="{FF2B5EF4-FFF2-40B4-BE49-F238E27FC236}">
+                <a16:creationId xmlns:a16="http://schemas.microsoft.com/office/drawing/2014/main" id="{C9E38B5A-9740-F616-56E9-6B09F1BDFCC9}"/>
+              </a:ext>
+            </a:extLst>
+          </p:cNvPr>
+          <p:cNvSpPr>
+            <a:spLocks noGrp="1"/>
+          </p:cNvSpPr>
+          <p:nvPr>
+            <p:ph type="body" idx="1"/>
+          </p:nvPr>
+        </p:nvSpPr>
+        <p:spPr/>
+        <p:txBody>
+          <a:bodyPr/>
+          <a:lstStyle/>
+          <a:p>
+            <a:r>
+              <a:rPr lang="es-AR" dirty="0"/>
+              <a:t>Escenario I</a:t>
+            </a:r>
+          </a:p>
+        </p:txBody>
+      </p:sp>
+      <p:sp>
+        <p:nvSpPr>
+          <p:cNvPr id="4" name="Marcador de posición de imagen 3">
+            <a:extLst>
+              <a:ext uri="{FF2B5EF4-FFF2-40B4-BE49-F238E27FC236}">
+                <a16:creationId xmlns:a16="http://schemas.microsoft.com/office/drawing/2014/main" id="{42FB580F-95CE-5778-EFAE-448A414F57C0}"/>
+              </a:ext>
+            </a:extLst>
+          </p:cNvPr>
+          <p:cNvSpPr>
+            <a:spLocks noGrp="1"/>
+          </p:cNvSpPr>
+          <p:nvPr>
+            <p:ph type="pic" idx="15"/>
+          </p:nvPr>
+        </p:nvSpPr>
+        <p:spPr/>
+        <p:txBody>
+          <a:bodyPr/>
+          <a:lstStyle/>
+          <a:p>
+            <a:endParaRPr lang="es-AR"/>
+          </a:p>
+        </p:txBody>
+      </p:sp>
+      <p:sp>
+        <p:nvSpPr>
+          <p:cNvPr id="5" name="Marcador de texto 4">
+            <a:extLst>
+              <a:ext uri="{FF2B5EF4-FFF2-40B4-BE49-F238E27FC236}">
+                <a16:creationId xmlns:a16="http://schemas.microsoft.com/office/drawing/2014/main" id="{4D8635DA-A474-9FA0-5956-B03AB36CC8DA}"/>
+              </a:ext>
+            </a:extLst>
+          </p:cNvPr>
+          <p:cNvSpPr>
+            <a:spLocks noGrp="1"/>
+          </p:cNvSpPr>
+          <p:nvPr>
+            <p:ph type="body" sz="half" idx="18"/>
+          </p:nvPr>
+        </p:nvSpPr>
+        <p:spPr/>
+        <p:txBody>
+          <a:bodyPr/>
+          <a:lstStyle/>
+          <a:p>
+            <a:r>
+              <a:rPr lang="es-AR" dirty="0"/>
+              <a:t>[histograma por servidor]</a:t>
+            </a:r>
+          </a:p>
+        </p:txBody>
+      </p:sp>
+      <p:sp>
+        <p:nvSpPr>
+          <p:cNvPr id="6" name="Marcador de texto 5">
+            <a:extLst>
+              <a:ext uri="{FF2B5EF4-FFF2-40B4-BE49-F238E27FC236}">
+                <a16:creationId xmlns:a16="http://schemas.microsoft.com/office/drawing/2014/main" id="{6A16B52B-133E-6A3D-0ECC-8612CC36AC03}"/>
+              </a:ext>
+            </a:extLst>
+          </p:cNvPr>
+          <p:cNvSpPr>
+            <a:spLocks noGrp="1"/>
+          </p:cNvSpPr>
+          <p:nvPr>
+            <p:ph type="body" sz="quarter" idx="3"/>
+          </p:nvPr>
+        </p:nvSpPr>
+        <p:spPr/>
+        <p:txBody>
+          <a:bodyPr/>
+          <a:lstStyle/>
+          <a:p>
+            <a:r>
+              <a:rPr lang="es-AR" dirty="0"/>
+              <a:t>Escenario II</a:t>
+            </a:r>
+          </a:p>
+        </p:txBody>
+      </p:sp>
+      <p:sp>
+        <p:nvSpPr>
+          <p:cNvPr id="7" name="Marcador de posición de imagen 6">
+            <a:extLst>
+              <a:ext uri="{FF2B5EF4-FFF2-40B4-BE49-F238E27FC236}">
+                <a16:creationId xmlns:a16="http://schemas.microsoft.com/office/drawing/2014/main" id="{FCB58165-9393-21AC-2390-A58514881DF7}"/>
+              </a:ext>
+            </a:extLst>
+          </p:cNvPr>
+          <p:cNvSpPr>
+            <a:spLocks noGrp="1"/>
+          </p:cNvSpPr>
+          <p:nvPr>
+            <p:ph type="pic" idx="21"/>
+          </p:nvPr>
+        </p:nvSpPr>
+        <p:spPr/>
+        <p:txBody>
+          <a:bodyPr/>
+          <a:lstStyle/>
+          <a:p>
+            <a:endParaRPr lang="es-AR"/>
+          </a:p>
+        </p:txBody>
+      </p:sp>
+      <p:sp>
+        <p:nvSpPr>
+          <p:cNvPr id="8" name="Marcador de texto 7">
+            <a:extLst>
+              <a:ext uri="{FF2B5EF4-FFF2-40B4-BE49-F238E27FC236}">
+                <a16:creationId xmlns:a16="http://schemas.microsoft.com/office/drawing/2014/main" id="{4C83EAC9-FA7A-8790-492A-B5235B18D12B}"/>
+              </a:ext>
+            </a:extLst>
+          </p:cNvPr>
+          <p:cNvSpPr>
+            <a:spLocks noGrp="1"/>
+          </p:cNvSpPr>
+          <p:nvPr>
+            <p:ph type="body" sz="half" idx="19"/>
+          </p:nvPr>
+        </p:nvSpPr>
+        <p:spPr/>
+        <p:txBody>
+          <a:bodyPr/>
+          <a:lstStyle/>
+          <a:p>
+            <a:endParaRPr lang="es-AR"/>
+          </a:p>
+        </p:txBody>
+      </p:sp>
+      <p:sp>
+        <p:nvSpPr>
+          <p:cNvPr id="9" name="Marcador de texto 8">
+            <a:extLst>
+              <a:ext uri="{FF2B5EF4-FFF2-40B4-BE49-F238E27FC236}">
+                <a16:creationId xmlns:a16="http://schemas.microsoft.com/office/drawing/2014/main" id="{0125C240-8FA0-DF59-3C77-0F59A6F34DA3}"/>
+              </a:ext>
+            </a:extLst>
+          </p:cNvPr>
+          <p:cNvSpPr>
+            <a:spLocks noGrp="1"/>
+          </p:cNvSpPr>
+          <p:nvPr>
+            <p:ph type="body" sz="quarter" idx="13"/>
+          </p:nvPr>
+        </p:nvSpPr>
+        <p:spPr/>
+        <p:txBody>
+          <a:bodyPr/>
+          <a:lstStyle/>
+          <a:p>
+            <a:r>
+              <a:rPr lang="es-AR" dirty="0"/>
+              <a:t>Escenario III</a:t>
+            </a:r>
+          </a:p>
+        </p:txBody>
+      </p:sp>
+      <p:sp>
+        <p:nvSpPr>
+          <p:cNvPr id="10" name="Marcador de posición de imagen 9">
+            <a:extLst>
+              <a:ext uri="{FF2B5EF4-FFF2-40B4-BE49-F238E27FC236}">
+                <a16:creationId xmlns:a16="http://schemas.microsoft.com/office/drawing/2014/main" id="{39E91B32-ED8B-E3D1-D6F9-FFF0AF40A3B1}"/>
+              </a:ext>
+            </a:extLst>
+          </p:cNvPr>
+          <p:cNvSpPr>
+            <a:spLocks noGrp="1"/>
+          </p:cNvSpPr>
+          <p:nvPr>
+            <p:ph type="pic" idx="22"/>
+          </p:nvPr>
+        </p:nvSpPr>
+        <p:spPr/>
+        <p:txBody>
+          <a:bodyPr/>
+          <a:lstStyle/>
+          <a:p>
+            <a:endParaRPr lang="es-AR"/>
+          </a:p>
+        </p:txBody>
+      </p:sp>
+      <p:sp>
+        <p:nvSpPr>
+          <p:cNvPr id="11" name="Marcador de texto 10">
+            <a:extLst>
+              <a:ext uri="{FF2B5EF4-FFF2-40B4-BE49-F238E27FC236}">
+                <a16:creationId xmlns:a16="http://schemas.microsoft.com/office/drawing/2014/main" id="{36B5AB14-1EF6-BD90-3BCB-93758F6C98AD}"/>
+              </a:ext>
+            </a:extLst>
+          </p:cNvPr>
+          <p:cNvSpPr>
+            <a:spLocks noGrp="1"/>
+          </p:cNvSpPr>
+          <p:nvPr>
+            <p:ph type="body" sz="half" idx="20"/>
+          </p:nvPr>
+        </p:nvSpPr>
+        <p:spPr/>
+        <p:txBody>
+          <a:bodyPr/>
+          <a:lstStyle/>
+          <a:p>
+            <a:endParaRPr lang="es-AR"/>
+          </a:p>
+        </p:txBody>
+      </p:sp>
+    </p:spTree>
+    <p:extLst>
+      <p:ext uri="{BB962C8B-B14F-4D97-AF65-F5344CB8AC3E}">
+        <p14:creationId xmlns:p14="http://schemas.microsoft.com/office/powerpoint/2010/main" val="3349947067"/>
+      </p:ext>
+    </p:extLst>
+  </p:cSld>
+  <p:clrMapOvr>
+    <a:masterClrMapping/>
+  </p:clrMapOvr>
+  <p:extLst>
+    <p:ext uri="{6950BFC3-D8DA-4A85-94F7-54DA5524770B}">
+      <p188:commentRel xmlns:p188="http://schemas.microsoft.com/office/powerpoint/2018/8/main" r:id="rId2"/>
+    </p:ext>
+  </p:extLst>
+</p:sld>
+</file>
+
+<file path=ppt/slides/slide16.xml><?xml version="1.0" encoding="utf-8"?>
+<p:sld xmlns:a="http://schemas.openxmlformats.org/drawingml/2006/main" xmlns:r="http://schemas.openxmlformats.org/officeDocument/2006/relationships" xmlns:p="http://schemas.openxmlformats.org/presentationml/2006/main">
+  <p:cSld>
+    <p:spTree>
+      <p:nvGrpSpPr>
+        <p:cNvPr id="1" name="">
+          <a:extLst>
+            <a:ext uri="{FF2B5EF4-FFF2-40B4-BE49-F238E27FC236}">
+              <a16:creationId xmlns:a16="http://schemas.microsoft.com/office/drawing/2014/main" id="{28E87128-ADE2-5040-ECA4-56CB7477BD3F}"/>
+            </a:ext>
+          </a:extLst>
+        </p:cNvPr>
+        <p:cNvGrpSpPr/>
+        <p:nvPr/>
+      </p:nvGrpSpPr>
+      <p:grpSpPr>
+        <a:xfrm>
+          <a:off x="0" y="0"/>
+          <a:ext cx="0" cy="0"/>
+          <a:chOff x="0" y="0"/>
+          <a:chExt cx="0" cy="0"/>
+        </a:xfrm>
+      </p:grpSpPr>
+      <p:sp>
+        <p:nvSpPr>
+          <p:cNvPr id="2" name="Título 1">
+            <a:extLst>
+              <a:ext uri="{FF2B5EF4-FFF2-40B4-BE49-F238E27FC236}">
+                <a16:creationId xmlns:a16="http://schemas.microsoft.com/office/drawing/2014/main" id="{59B0438D-DB8E-CE54-E367-E4A8E991FAE4}"/>
+              </a:ext>
+            </a:extLst>
+          </p:cNvPr>
+          <p:cNvSpPr>
+            <a:spLocks noGrp="1"/>
+          </p:cNvSpPr>
+          <p:nvPr>
+            <p:ph type="title"/>
+          </p:nvPr>
+        </p:nvSpPr>
+        <p:spPr/>
+        <p:txBody>
+          <a:bodyPr/>
+          <a:lstStyle/>
+          <a:p>
+            <a:r>
+              <a:rPr lang="es-AR" dirty="0"/>
+              <a:t>Porcentaje tiempo ocioso servidores Clase A</a:t>
+            </a:r>
+          </a:p>
+        </p:txBody>
+      </p:sp>
+      <p:sp>
+        <p:nvSpPr>
+          <p:cNvPr id="3" name="Marcador de texto 2">
+            <a:extLst>
+              <a:ext uri="{FF2B5EF4-FFF2-40B4-BE49-F238E27FC236}">
+                <a16:creationId xmlns:a16="http://schemas.microsoft.com/office/drawing/2014/main" id="{D770D2C9-ED45-D99B-E144-92BDE72454D9}"/>
+              </a:ext>
+            </a:extLst>
+          </p:cNvPr>
+          <p:cNvSpPr>
+            <a:spLocks noGrp="1"/>
+          </p:cNvSpPr>
+          <p:nvPr>
+            <p:ph type="body" idx="1"/>
+          </p:nvPr>
+        </p:nvSpPr>
+        <p:spPr/>
+        <p:txBody>
+          <a:bodyPr/>
+          <a:lstStyle/>
+          <a:p>
+            <a:r>
+              <a:rPr lang="es-AR" dirty="0"/>
+              <a:t>Escenario IV</a:t>
+            </a:r>
+          </a:p>
+        </p:txBody>
+      </p:sp>
+      <p:sp>
+        <p:nvSpPr>
+          <p:cNvPr id="4" name="Marcador de posición de imagen 3">
+            <a:extLst>
+              <a:ext uri="{FF2B5EF4-FFF2-40B4-BE49-F238E27FC236}">
+                <a16:creationId xmlns:a16="http://schemas.microsoft.com/office/drawing/2014/main" id="{20328783-355C-64FB-D726-6CE653BFD5CF}"/>
+              </a:ext>
+            </a:extLst>
+          </p:cNvPr>
+          <p:cNvSpPr>
+            <a:spLocks noGrp="1"/>
+          </p:cNvSpPr>
+          <p:nvPr>
+            <p:ph type="pic" idx="15"/>
+          </p:nvPr>
+        </p:nvSpPr>
+        <p:spPr/>
+        <p:txBody>
+          <a:bodyPr/>
+          <a:lstStyle/>
+          <a:p>
+            <a:endParaRPr lang="es-AR"/>
+          </a:p>
+        </p:txBody>
+      </p:sp>
+      <p:sp>
+        <p:nvSpPr>
+          <p:cNvPr id="5" name="Marcador de texto 4">
+            <a:extLst>
+              <a:ext uri="{FF2B5EF4-FFF2-40B4-BE49-F238E27FC236}">
+                <a16:creationId xmlns:a16="http://schemas.microsoft.com/office/drawing/2014/main" id="{17DDA62F-2931-051F-D635-42003D4251C9}"/>
+              </a:ext>
+            </a:extLst>
+          </p:cNvPr>
+          <p:cNvSpPr>
+            <a:spLocks noGrp="1"/>
+          </p:cNvSpPr>
+          <p:nvPr>
+            <p:ph type="body" sz="half" idx="18"/>
+          </p:nvPr>
+        </p:nvSpPr>
+        <p:spPr/>
+        <p:txBody>
+          <a:bodyPr/>
+          <a:lstStyle/>
+          <a:p>
+            <a:endParaRPr lang="es-AR"/>
+          </a:p>
+        </p:txBody>
+      </p:sp>
+      <p:sp>
+        <p:nvSpPr>
+          <p:cNvPr id="6" name="Marcador de texto 5">
+            <a:extLst>
+              <a:ext uri="{FF2B5EF4-FFF2-40B4-BE49-F238E27FC236}">
+                <a16:creationId xmlns:a16="http://schemas.microsoft.com/office/drawing/2014/main" id="{25FB40D9-A3A5-1351-02EE-76233279B864}"/>
+              </a:ext>
+            </a:extLst>
+          </p:cNvPr>
+          <p:cNvSpPr>
+            <a:spLocks noGrp="1"/>
+          </p:cNvSpPr>
+          <p:nvPr>
+            <p:ph type="body" sz="quarter" idx="3"/>
+          </p:nvPr>
+        </p:nvSpPr>
+        <p:spPr/>
+        <p:txBody>
+          <a:bodyPr/>
+          <a:lstStyle/>
+          <a:p>
+            <a:r>
+              <a:rPr lang="es-AR" dirty="0"/>
+              <a:t>Escenario V</a:t>
+            </a:r>
+          </a:p>
+        </p:txBody>
+      </p:sp>
+      <p:sp>
+        <p:nvSpPr>
+          <p:cNvPr id="7" name="Marcador de posición de imagen 6">
+            <a:extLst>
+              <a:ext uri="{FF2B5EF4-FFF2-40B4-BE49-F238E27FC236}">
+                <a16:creationId xmlns:a16="http://schemas.microsoft.com/office/drawing/2014/main" id="{E6B42987-48AF-9B70-3F39-B827CDE4FB28}"/>
+              </a:ext>
+            </a:extLst>
+          </p:cNvPr>
+          <p:cNvSpPr>
+            <a:spLocks noGrp="1"/>
+          </p:cNvSpPr>
+          <p:nvPr>
+            <p:ph type="pic" idx="21"/>
+          </p:nvPr>
+        </p:nvSpPr>
+        <p:spPr/>
+        <p:txBody>
+          <a:bodyPr/>
+          <a:lstStyle/>
+          <a:p>
+            <a:endParaRPr lang="es-AR"/>
+          </a:p>
+        </p:txBody>
+      </p:sp>
+      <p:sp>
+        <p:nvSpPr>
+          <p:cNvPr id="8" name="Marcador de texto 7">
+            <a:extLst>
+              <a:ext uri="{FF2B5EF4-FFF2-40B4-BE49-F238E27FC236}">
+                <a16:creationId xmlns:a16="http://schemas.microsoft.com/office/drawing/2014/main" id="{8FC91ACF-66FE-4945-E519-C96EEBA7DD14}"/>
+              </a:ext>
+            </a:extLst>
+          </p:cNvPr>
+          <p:cNvSpPr>
+            <a:spLocks noGrp="1"/>
+          </p:cNvSpPr>
+          <p:nvPr>
+            <p:ph type="body" sz="half" idx="19"/>
+          </p:nvPr>
+        </p:nvSpPr>
+        <p:spPr/>
+        <p:txBody>
+          <a:bodyPr/>
+          <a:lstStyle/>
+          <a:p>
+            <a:endParaRPr lang="es-AR" dirty="0"/>
+          </a:p>
+        </p:txBody>
+      </p:sp>
+    </p:spTree>
+    <p:extLst>
+      <p:ext uri="{BB962C8B-B14F-4D97-AF65-F5344CB8AC3E}">
+        <p14:creationId xmlns:p14="http://schemas.microsoft.com/office/powerpoint/2010/main" val="1546194755"/>
+      </p:ext>
+    </p:extLst>
+  </p:cSld>
+  <p:clrMapOvr>
+    <a:masterClrMapping/>
+  </p:clrMapOvr>
+</p:sld>
+</file>
+
+<file path=ppt/slides/slide17.xml><?xml version="1.0" encoding="utf-8"?>
+<p:sld xmlns:a="http://schemas.openxmlformats.org/drawingml/2006/main" xmlns:r="http://schemas.openxmlformats.org/officeDocument/2006/relationships" xmlns:p="http://schemas.openxmlformats.org/presentationml/2006/main">
+  <p:cSld>
+    <p:spTree>
+      <p:nvGrpSpPr>
+        <p:cNvPr id="1" name="">
+          <a:extLst>
+            <a:ext uri="{FF2B5EF4-FFF2-40B4-BE49-F238E27FC236}">
+              <a16:creationId xmlns:a16="http://schemas.microsoft.com/office/drawing/2014/main" id="{36991356-5400-2A12-B4FA-33157B664164}"/>
+            </a:ext>
+          </a:extLst>
+        </p:cNvPr>
+        <p:cNvGrpSpPr/>
+        <p:nvPr/>
+      </p:nvGrpSpPr>
+      <p:grpSpPr>
+        <a:xfrm>
+          <a:off x="0" y="0"/>
+          <a:ext cx="0" cy="0"/>
+          <a:chOff x="0" y="0"/>
+          <a:chExt cx="0" cy="0"/>
+        </a:xfrm>
+      </p:grpSpPr>
+      <p:sp>
+        <p:nvSpPr>
+          <p:cNvPr id="2" name="Título 1">
+            <a:extLst>
+              <a:ext uri="{FF2B5EF4-FFF2-40B4-BE49-F238E27FC236}">
+                <a16:creationId xmlns:a16="http://schemas.microsoft.com/office/drawing/2014/main" id="{86118E2B-5EB7-6029-AEBC-3CB415F601B7}"/>
+              </a:ext>
+            </a:extLst>
+          </p:cNvPr>
+          <p:cNvSpPr>
+            <a:spLocks noGrp="1"/>
+          </p:cNvSpPr>
+          <p:nvPr>
+            <p:ph type="title"/>
+          </p:nvPr>
+        </p:nvSpPr>
+        <p:spPr/>
+        <p:txBody>
+          <a:bodyPr/>
+          <a:lstStyle/>
+          <a:p>
+            <a:r>
+              <a:rPr lang="es-AR" dirty="0"/>
+              <a:t>Porcentaje tiempo ocioso servidores Clase B</a:t>
+            </a:r>
+          </a:p>
+        </p:txBody>
+      </p:sp>
+      <p:sp>
+        <p:nvSpPr>
+          <p:cNvPr id="3" name="Marcador de texto 2">
+            <a:extLst>
+              <a:ext uri="{FF2B5EF4-FFF2-40B4-BE49-F238E27FC236}">
+                <a16:creationId xmlns:a16="http://schemas.microsoft.com/office/drawing/2014/main" id="{C82DB5BD-168C-7BB4-F68A-A8C450BB7559}"/>
+              </a:ext>
+            </a:extLst>
+          </p:cNvPr>
+          <p:cNvSpPr>
+            <a:spLocks noGrp="1"/>
+          </p:cNvSpPr>
+          <p:nvPr>
+            <p:ph type="body" idx="1"/>
+          </p:nvPr>
+        </p:nvSpPr>
+        <p:spPr/>
+        <p:txBody>
+          <a:bodyPr/>
+          <a:lstStyle/>
+          <a:p>
+            <a:r>
+              <a:rPr lang="es-AR" dirty="0"/>
+              <a:t>Escenario I</a:t>
+            </a:r>
+          </a:p>
+        </p:txBody>
+      </p:sp>
+      <p:sp>
+        <p:nvSpPr>
+          <p:cNvPr id="4" name="Marcador de posición de imagen 3">
+            <a:extLst>
+              <a:ext uri="{FF2B5EF4-FFF2-40B4-BE49-F238E27FC236}">
+                <a16:creationId xmlns:a16="http://schemas.microsoft.com/office/drawing/2014/main" id="{386E9D95-7CA2-C9D9-2750-055AEDC33904}"/>
+              </a:ext>
+            </a:extLst>
+          </p:cNvPr>
+          <p:cNvSpPr>
+            <a:spLocks noGrp="1"/>
+          </p:cNvSpPr>
+          <p:nvPr>
+            <p:ph type="pic" idx="15"/>
+          </p:nvPr>
+        </p:nvSpPr>
+        <p:spPr/>
+        <p:txBody>
+          <a:bodyPr/>
+          <a:lstStyle/>
+          <a:p>
+            <a:endParaRPr lang="es-AR"/>
+          </a:p>
+        </p:txBody>
+      </p:sp>
+      <p:sp>
+        <p:nvSpPr>
+          <p:cNvPr id="5" name="Marcador de texto 4">
+            <a:extLst>
+              <a:ext uri="{FF2B5EF4-FFF2-40B4-BE49-F238E27FC236}">
+                <a16:creationId xmlns:a16="http://schemas.microsoft.com/office/drawing/2014/main" id="{16B1CB39-849E-A8A0-9378-87507246574C}"/>
+              </a:ext>
+            </a:extLst>
+          </p:cNvPr>
+          <p:cNvSpPr>
+            <a:spLocks noGrp="1"/>
+          </p:cNvSpPr>
+          <p:nvPr>
+            <p:ph type="body" sz="half" idx="18"/>
+          </p:nvPr>
+        </p:nvSpPr>
+        <p:spPr/>
+        <p:txBody>
+          <a:bodyPr/>
+          <a:lstStyle/>
+          <a:p>
+            <a:r>
+              <a:rPr lang="es-AR" dirty="0"/>
+              <a:t>[histograma por servidor]</a:t>
+            </a:r>
+          </a:p>
+        </p:txBody>
+      </p:sp>
+      <p:sp>
+        <p:nvSpPr>
+          <p:cNvPr id="6" name="Marcador de texto 5">
+            <a:extLst>
+              <a:ext uri="{FF2B5EF4-FFF2-40B4-BE49-F238E27FC236}">
+                <a16:creationId xmlns:a16="http://schemas.microsoft.com/office/drawing/2014/main" id="{FECD03B8-676C-AB48-83B8-1E6540D35DAF}"/>
+              </a:ext>
+            </a:extLst>
+          </p:cNvPr>
+          <p:cNvSpPr>
+            <a:spLocks noGrp="1"/>
+          </p:cNvSpPr>
+          <p:nvPr>
+            <p:ph type="body" sz="quarter" idx="3"/>
+          </p:nvPr>
+        </p:nvSpPr>
+        <p:spPr/>
+        <p:txBody>
+          <a:bodyPr/>
+          <a:lstStyle/>
+          <a:p>
+            <a:r>
+              <a:rPr lang="es-AR" dirty="0"/>
+              <a:t>Escenario II</a:t>
+            </a:r>
+          </a:p>
+        </p:txBody>
+      </p:sp>
+      <p:sp>
+        <p:nvSpPr>
+          <p:cNvPr id="7" name="Marcador de posición de imagen 6">
+            <a:extLst>
+              <a:ext uri="{FF2B5EF4-FFF2-40B4-BE49-F238E27FC236}">
+                <a16:creationId xmlns:a16="http://schemas.microsoft.com/office/drawing/2014/main" id="{1F75C7B4-FABA-3DC6-E8C5-B42785E43BF0}"/>
+              </a:ext>
+            </a:extLst>
+          </p:cNvPr>
+          <p:cNvSpPr>
+            <a:spLocks noGrp="1"/>
+          </p:cNvSpPr>
+          <p:nvPr>
+            <p:ph type="pic" idx="21"/>
+          </p:nvPr>
+        </p:nvSpPr>
+        <p:spPr/>
+        <p:txBody>
+          <a:bodyPr/>
+          <a:lstStyle/>
+          <a:p>
+            <a:endParaRPr lang="es-AR"/>
+          </a:p>
+        </p:txBody>
+      </p:sp>
+      <p:sp>
+        <p:nvSpPr>
+          <p:cNvPr id="8" name="Marcador de texto 7">
+            <a:extLst>
+              <a:ext uri="{FF2B5EF4-FFF2-40B4-BE49-F238E27FC236}">
+                <a16:creationId xmlns:a16="http://schemas.microsoft.com/office/drawing/2014/main" id="{A4B33CDB-755E-91E3-5B89-7E20C6342575}"/>
+              </a:ext>
+            </a:extLst>
+          </p:cNvPr>
+          <p:cNvSpPr>
+            <a:spLocks noGrp="1"/>
+          </p:cNvSpPr>
+          <p:nvPr>
+            <p:ph type="body" sz="half" idx="19"/>
+          </p:nvPr>
+        </p:nvSpPr>
+        <p:spPr/>
+        <p:txBody>
+          <a:bodyPr/>
+          <a:lstStyle/>
+          <a:p>
+            <a:endParaRPr lang="es-AR"/>
+          </a:p>
+        </p:txBody>
+      </p:sp>
+      <p:sp>
+        <p:nvSpPr>
+          <p:cNvPr id="9" name="Marcador de texto 8">
+            <a:extLst>
+              <a:ext uri="{FF2B5EF4-FFF2-40B4-BE49-F238E27FC236}">
+                <a16:creationId xmlns:a16="http://schemas.microsoft.com/office/drawing/2014/main" id="{8CB9F7CE-B32D-4945-F226-E9BFA0E09769}"/>
+              </a:ext>
+            </a:extLst>
+          </p:cNvPr>
+          <p:cNvSpPr>
+            <a:spLocks noGrp="1"/>
+          </p:cNvSpPr>
+          <p:nvPr>
+            <p:ph type="body" sz="quarter" idx="13"/>
+          </p:nvPr>
+        </p:nvSpPr>
+        <p:spPr/>
+        <p:txBody>
+          <a:bodyPr/>
+          <a:lstStyle/>
+          <a:p>
+            <a:r>
+              <a:rPr lang="es-AR" dirty="0"/>
+              <a:t>Escenario III</a:t>
+            </a:r>
+          </a:p>
+        </p:txBody>
+      </p:sp>
+      <p:sp>
+        <p:nvSpPr>
+          <p:cNvPr id="10" name="Marcador de posición de imagen 9">
+            <a:extLst>
+              <a:ext uri="{FF2B5EF4-FFF2-40B4-BE49-F238E27FC236}">
+                <a16:creationId xmlns:a16="http://schemas.microsoft.com/office/drawing/2014/main" id="{5BB9AB00-8AE9-55A9-300B-C7B271536AAD}"/>
+              </a:ext>
+            </a:extLst>
+          </p:cNvPr>
+          <p:cNvSpPr>
+            <a:spLocks noGrp="1"/>
+          </p:cNvSpPr>
+          <p:nvPr>
+            <p:ph type="pic" idx="22"/>
+          </p:nvPr>
+        </p:nvSpPr>
+        <p:spPr/>
+        <p:txBody>
+          <a:bodyPr/>
+          <a:lstStyle/>
+          <a:p>
+            <a:endParaRPr lang="es-AR"/>
+          </a:p>
+        </p:txBody>
+      </p:sp>
+      <p:sp>
+        <p:nvSpPr>
+          <p:cNvPr id="11" name="Marcador de texto 10">
+            <a:extLst>
+              <a:ext uri="{FF2B5EF4-FFF2-40B4-BE49-F238E27FC236}">
+                <a16:creationId xmlns:a16="http://schemas.microsoft.com/office/drawing/2014/main" id="{49DF2CD4-2638-193E-FB4E-E2D1D7FE03C4}"/>
+              </a:ext>
+            </a:extLst>
+          </p:cNvPr>
+          <p:cNvSpPr>
+            <a:spLocks noGrp="1"/>
+          </p:cNvSpPr>
+          <p:nvPr>
+            <p:ph type="body" sz="half" idx="20"/>
+          </p:nvPr>
+        </p:nvSpPr>
+        <p:spPr/>
+        <p:txBody>
+          <a:bodyPr/>
+          <a:lstStyle/>
+          <a:p>
+            <a:endParaRPr lang="es-AR"/>
+          </a:p>
+        </p:txBody>
+      </p:sp>
+    </p:spTree>
+    <p:extLst>
+      <p:ext uri="{BB962C8B-B14F-4D97-AF65-F5344CB8AC3E}">
+        <p14:creationId xmlns:p14="http://schemas.microsoft.com/office/powerpoint/2010/main" val="3899864669"/>
+      </p:ext>
+    </p:extLst>
+  </p:cSld>
+  <p:clrMapOvr>
+    <a:masterClrMapping/>
+  </p:clrMapOvr>
+  <p:extLst>
+    <p:ext uri="{6950BFC3-D8DA-4A85-94F7-54DA5524770B}">
+      <p188:commentRel xmlns:p188="http://schemas.microsoft.com/office/powerpoint/2018/8/main" r:id="rId2"/>
+    </p:ext>
+  </p:extLst>
+</p:sld>
+</file>
+
+<file path=ppt/slides/slide18.xml><?xml version="1.0" encoding="utf-8"?>
+<p:sld xmlns:a="http://schemas.openxmlformats.org/drawingml/2006/main" xmlns:r="http://schemas.openxmlformats.org/officeDocument/2006/relationships" xmlns:p="http://schemas.openxmlformats.org/presentationml/2006/main">
+  <p:cSld>
+    <p:spTree>
+      <p:nvGrpSpPr>
+        <p:cNvPr id="1" name="">
+          <a:extLst>
+            <a:ext uri="{FF2B5EF4-FFF2-40B4-BE49-F238E27FC236}">
+              <a16:creationId xmlns:a16="http://schemas.microsoft.com/office/drawing/2014/main" id="{097DE51F-3591-8D27-E0BB-E272595F171C}"/>
+            </a:ext>
+          </a:extLst>
+        </p:cNvPr>
+        <p:cNvGrpSpPr/>
+        <p:nvPr/>
+      </p:nvGrpSpPr>
+      <p:grpSpPr>
+        <a:xfrm>
+          <a:off x="0" y="0"/>
+          <a:ext cx="0" cy="0"/>
+          <a:chOff x="0" y="0"/>
+          <a:chExt cx="0" cy="0"/>
+        </a:xfrm>
+      </p:grpSpPr>
+      <p:sp>
+        <p:nvSpPr>
+          <p:cNvPr id="2" name="Título 1">
+            <a:extLst>
+              <a:ext uri="{FF2B5EF4-FFF2-40B4-BE49-F238E27FC236}">
+                <a16:creationId xmlns:a16="http://schemas.microsoft.com/office/drawing/2014/main" id="{33B0CCF4-44EC-4BE2-FDA6-95BC359CF58C}"/>
+              </a:ext>
+            </a:extLst>
+          </p:cNvPr>
+          <p:cNvSpPr>
+            <a:spLocks noGrp="1"/>
+          </p:cNvSpPr>
+          <p:nvPr>
+            <p:ph type="title"/>
+          </p:nvPr>
+        </p:nvSpPr>
+        <p:spPr/>
+        <p:txBody>
+          <a:bodyPr/>
+          <a:lstStyle/>
+          <a:p>
+            <a:r>
+              <a:rPr lang="es-AR" dirty="0"/>
+              <a:t>Porcentaje tiempo ocioso servidores Clase B</a:t>
+            </a:r>
+          </a:p>
+        </p:txBody>
+      </p:sp>
+      <p:sp>
+        <p:nvSpPr>
+          <p:cNvPr id="3" name="Marcador de texto 2">
+            <a:extLst>
+              <a:ext uri="{FF2B5EF4-FFF2-40B4-BE49-F238E27FC236}">
+                <a16:creationId xmlns:a16="http://schemas.microsoft.com/office/drawing/2014/main" id="{C3DA2B2A-7AC1-3694-C16D-344D613620A5}"/>
+              </a:ext>
+            </a:extLst>
+          </p:cNvPr>
+          <p:cNvSpPr>
+            <a:spLocks noGrp="1"/>
+          </p:cNvSpPr>
+          <p:nvPr>
+            <p:ph type="body" idx="1"/>
+          </p:nvPr>
+        </p:nvSpPr>
+        <p:spPr/>
+        <p:txBody>
+          <a:bodyPr/>
+          <a:lstStyle/>
+          <a:p>
+            <a:r>
+              <a:rPr lang="es-AR" dirty="0"/>
+              <a:t>Escenario IV</a:t>
+            </a:r>
+          </a:p>
+        </p:txBody>
+      </p:sp>
+      <p:sp>
+        <p:nvSpPr>
+          <p:cNvPr id="4" name="Marcador de posición de imagen 3">
+            <a:extLst>
+              <a:ext uri="{FF2B5EF4-FFF2-40B4-BE49-F238E27FC236}">
+                <a16:creationId xmlns:a16="http://schemas.microsoft.com/office/drawing/2014/main" id="{5E70982D-8D16-A19C-2F29-228471A42991}"/>
+              </a:ext>
+            </a:extLst>
+          </p:cNvPr>
+          <p:cNvSpPr>
+            <a:spLocks noGrp="1"/>
+          </p:cNvSpPr>
+          <p:nvPr>
+            <p:ph type="pic" idx="15"/>
+          </p:nvPr>
+        </p:nvSpPr>
+        <p:spPr/>
+        <p:txBody>
+          <a:bodyPr/>
+          <a:lstStyle/>
+          <a:p>
+            <a:endParaRPr lang="es-AR"/>
+          </a:p>
+        </p:txBody>
+      </p:sp>
+      <p:sp>
+        <p:nvSpPr>
+          <p:cNvPr id="5" name="Marcador de texto 4">
+            <a:extLst>
+              <a:ext uri="{FF2B5EF4-FFF2-40B4-BE49-F238E27FC236}">
+                <a16:creationId xmlns:a16="http://schemas.microsoft.com/office/drawing/2014/main" id="{A71272FF-14B2-8816-97CB-B79E6329E7A0}"/>
+              </a:ext>
+            </a:extLst>
+          </p:cNvPr>
+          <p:cNvSpPr>
+            <a:spLocks noGrp="1"/>
+          </p:cNvSpPr>
+          <p:nvPr>
+            <p:ph type="body" sz="half" idx="18"/>
+          </p:nvPr>
+        </p:nvSpPr>
+        <p:spPr/>
+        <p:txBody>
+          <a:bodyPr/>
+          <a:lstStyle/>
+          <a:p>
+            <a:endParaRPr lang="es-AR"/>
+          </a:p>
+        </p:txBody>
+      </p:sp>
+      <p:sp>
+        <p:nvSpPr>
+          <p:cNvPr id="6" name="Marcador de texto 5">
+            <a:extLst>
+              <a:ext uri="{FF2B5EF4-FFF2-40B4-BE49-F238E27FC236}">
+                <a16:creationId xmlns:a16="http://schemas.microsoft.com/office/drawing/2014/main" id="{DD02BFA9-A2D5-AA74-2B4F-18BDECB08907}"/>
+              </a:ext>
+            </a:extLst>
+          </p:cNvPr>
+          <p:cNvSpPr>
+            <a:spLocks noGrp="1"/>
+          </p:cNvSpPr>
+          <p:nvPr>
+            <p:ph type="body" sz="quarter" idx="3"/>
+          </p:nvPr>
+        </p:nvSpPr>
+        <p:spPr/>
+        <p:txBody>
+          <a:bodyPr/>
+          <a:lstStyle/>
+          <a:p>
+            <a:r>
+              <a:rPr lang="es-AR" dirty="0"/>
+              <a:t>Escenario V</a:t>
+            </a:r>
+          </a:p>
+        </p:txBody>
+      </p:sp>
+      <p:sp>
+        <p:nvSpPr>
+          <p:cNvPr id="7" name="Marcador de posición de imagen 6">
+            <a:extLst>
+              <a:ext uri="{FF2B5EF4-FFF2-40B4-BE49-F238E27FC236}">
+                <a16:creationId xmlns:a16="http://schemas.microsoft.com/office/drawing/2014/main" id="{E9D613F2-2AC9-D448-85ED-7CFC1E2C5903}"/>
+              </a:ext>
+            </a:extLst>
+          </p:cNvPr>
+          <p:cNvSpPr>
+            <a:spLocks noGrp="1"/>
+          </p:cNvSpPr>
+          <p:nvPr>
+            <p:ph type="pic" idx="21"/>
+          </p:nvPr>
+        </p:nvSpPr>
+        <p:spPr/>
+        <p:txBody>
+          <a:bodyPr/>
+          <a:lstStyle/>
+          <a:p>
+            <a:endParaRPr lang="es-AR"/>
+          </a:p>
+        </p:txBody>
+      </p:sp>
+      <p:sp>
+        <p:nvSpPr>
+          <p:cNvPr id="8" name="Marcador de texto 7">
+            <a:extLst>
+              <a:ext uri="{FF2B5EF4-FFF2-40B4-BE49-F238E27FC236}">
+                <a16:creationId xmlns:a16="http://schemas.microsoft.com/office/drawing/2014/main" id="{9E1DD6F6-7420-A0AC-37EA-6EFF79108219}"/>
+              </a:ext>
+            </a:extLst>
+          </p:cNvPr>
+          <p:cNvSpPr>
+            <a:spLocks noGrp="1"/>
+          </p:cNvSpPr>
+          <p:nvPr>
+            <p:ph type="body" sz="half" idx="19"/>
+          </p:nvPr>
+        </p:nvSpPr>
+        <p:spPr/>
+        <p:txBody>
+          <a:bodyPr/>
+          <a:lstStyle/>
+          <a:p>
+            <a:endParaRPr lang="es-AR" dirty="0"/>
+          </a:p>
+        </p:txBody>
+      </p:sp>
+    </p:spTree>
+    <p:extLst>
+      <p:ext uri="{BB962C8B-B14F-4D97-AF65-F5344CB8AC3E}">
+        <p14:creationId xmlns:p14="http://schemas.microsoft.com/office/powerpoint/2010/main" val="527588311"/>
+      </p:ext>
+    </p:extLst>
+  </p:cSld>
+  <p:clrMapOvr>
+    <a:masterClrMapping/>
+  </p:clrMapOvr>
+</p:sld>
+</file>
+
+<file path=ppt/slides/slide19.xml><?xml version="1.0" encoding="utf-8"?>
+<p:sld xmlns:a="http://schemas.openxmlformats.org/drawingml/2006/main" xmlns:r="http://schemas.openxmlformats.org/officeDocument/2006/relationships" xmlns:p="http://schemas.openxmlformats.org/presentationml/2006/main">
+  <p:cSld>
+    <p:spTree>
+      <p:nvGrpSpPr>
+        <p:cNvPr id="1" name="">
+          <a:extLst>
+            <a:ext uri="{FF2B5EF4-FFF2-40B4-BE49-F238E27FC236}">
+              <a16:creationId xmlns:a16="http://schemas.microsoft.com/office/drawing/2014/main" id="{89C78018-46C8-8EEA-859D-0A3DA7B6D349}"/>
+            </a:ext>
+          </a:extLst>
+        </p:cNvPr>
+        <p:cNvGrpSpPr/>
+        <p:nvPr/>
+      </p:nvGrpSpPr>
+      <p:grpSpPr>
+        <a:xfrm>
+          <a:off x="0" y="0"/>
+          <a:ext cx="0" cy="0"/>
+          <a:chOff x="0" y="0"/>
+          <a:chExt cx="0" cy="0"/>
+        </a:xfrm>
+      </p:grpSpPr>
+      <p:sp>
+        <p:nvSpPr>
+          <p:cNvPr id="2" name="Título 1">
+            <a:extLst>
+              <a:ext uri="{FF2B5EF4-FFF2-40B4-BE49-F238E27FC236}">
+                <a16:creationId xmlns:a16="http://schemas.microsoft.com/office/drawing/2014/main" id="{3B9ACFB3-3B60-3E46-03CC-D27E188177E4}"/>
+              </a:ext>
+            </a:extLst>
+          </p:cNvPr>
+          <p:cNvSpPr>
+            <a:spLocks noGrp="1"/>
+          </p:cNvSpPr>
+          <p:nvPr>
+            <p:ph type="title"/>
+          </p:nvPr>
+        </p:nvSpPr>
+        <p:spPr/>
+        <p:txBody>
+          <a:bodyPr/>
+          <a:lstStyle/>
+          <a:p>
+            <a:r>
+              <a:rPr lang="es-AR" dirty="0"/>
+              <a:t>Porcentaje de flujos arrepentidos</a:t>
+            </a:r>
+          </a:p>
+        </p:txBody>
+      </p:sp>
+      <p:sp>
+        <p:nvSpPr>
+          <p:cNvPr id="3" name="Marcador de texto 2">
+            <a:extLst>
+              <a:ext uri="{FF2B5EF4-FFF2-40B4-BE49-F238E27FC236}">
+                <a16:creationId xmlns:a16="http://schemas.microsoft.com/office/drawing/2014/main" id="{3532701E-10E2-B2C0-90FE-F79FF493793B}"/>
+              </a:ext>
+            </a:extLst>
+          </p:cNvPr>
+          <p:cNvSpPr>
+            <a:spLocks noGrp="1"/>
+          </p:cNvSpPr>
+          <p:nvPr>
+            <p:ph type="body" idx="1"/>
+          </p:nvPr>
+        </p:nvSpPr>
+        <p:spPr/>
+        <p:txBody>
+          <a:bodyPr/>
+          <a:lstStyle/>
+          <a:p>
+            <a:r>
+              <a:rPr lang="es-AR" dirty="0"/>
+              <a:t>Escenario I</a:t>
+            </a:r>
+          </a:p>
+        </p:txBody>
+      </p:sp>
+      <p:sp>
+        <p:nvSpPr>
+          <p:cNvPr id="4" name="Marcador de posición de imagen 3">
+            <a:extLst>
+              <a:ext uri="{FF2B5EF4-FFF2-40B4-BE49-F238E27FC236}">
+                <a16:creationId xmlns:a16="http://schemas.microsoft.com/office/drawing/2014/main" id="{FE5D9299-C590-B512-C887-A9FC0B281C2F}"/>
+              </a:ext>
+            </a:extLst>
+          </p:cNvPr>
+          <p:cNvSpPr>
+            <a:spLocks noGrp="1"/>
+          </p:cNvSpPr>
+          <p:nvPr>
+            <p:ph type="pic" idx="15"/>
+          </p:nvPr>
+        </p:nvSpPr>
+        <p:spPr/>
+        <p:txBody>
+          <a:bodyPr/>
+          <a:lstStyle/>
+          <a:p>
+            <a:endParaRPr lang="es-AR"/>
+          </a:p>
+        </p:txBody>
+      </p:sp>
+      <p:sp>
+        <p:nvSpPr>
+          <p:cNvPr id="5" name="Marcador de texto 4">
+            <a:extLst>
+              <a:ext uri="{FF2B5EF4-FFF2-40B4-BE49-F238E27FC236}">
+                <a16:creationId xmlns:a16="http://schemas.microsoft.com/office/drawing/2014/main" id="{AAB07E8E-6C8C-BFE5-8FF4-862EF544B51B}"/>
+              </a:ext>
+            </a:extLst>
+          </p:cNvPr>
+          <p:cNvSpPr>
+            <a:spLocks noGrp="1"/>
+          </p:cNvSpPr>
+          <p:nvPr>
+            <p:ph type="body" sz="half" idx="18"/>
+          </p:nvPr>
+        </p:nvSpPr>
+        <p:spPr/>
+        <p:txBody>
+          <a:bodyPr/>
+          <a:lstStyle/>
+          <a:p>
+            <a:r>
+              <a:rPr lang="es-AR" dirty="0"/>
+              <a:t>[torta: procesados, arrepentidos UDP, arrepentidos TCP]</a:t>
+            </a:r>
+          </a:p>
+        </p:txBody>
+      </p:sp>
+      <p:sp>
+        <p:nvSpPr>
+          <p:cNvPr id="6" name="Marcador de texto 5">
+            <a:extLst>
+              <a:ext uri="{FF2B5EF4-FFF2-40B4-BE49-F238E27FC236}">
+                <a16:creationId xmlns:a16="http://schemas.microsoft.com/office/drawing/2014/main" id="{230FE7A4-37F5-1504-C712-D35D82942888}"/>
+              </a:ext>
+            </a:extLst>
+          </p:cNvPr>
+          <p:cNvSpPr>
+            <a:spLocks noGrp="1"/>
+          </p:cNvSpPr>
+          <p:nvPr>
+            <p:ph type="body" sz="quarter" idx="3"/>
+          </p:nvPr>
+        </p:nvSpPr>
+        <p:spPr/>
+        <p:txBody>
+          <a:bodyPr/>
+          <a:lstStyle/>
+          <a:p>
+            <a:r>
+              <a:rPr lang="es-AR" dirty="0"/>
+              <a:t>Escenario II</a:t>
+            </a:r>
+          </a:p>
+        </p:txBody>
+      </p:sp>
+      <p:sp>
+        <p:nvSpPr>
+          <p:cNvPr id="7" name="Marcador de posición de imagen 6">
+            <a:extLst>
+              <a:ext uri="{FF2B5EF4-FFF2-40B4-BE49-F238E27FC236}">
+                <a16:creationId xmlns:a16="http://schemas.microsoft.com/office/drawing/2014/main" id="{2DE3F5E8-6A32-8136-7B94-D433D6D221A3}"/>
+              </a:ext>
+            </a:extLst>
+          </p:cNvPr>
+          <p:cNvSpPr>
+            <a:spLocks noGrp="1"/>
+          </p:cNvSpPr>
+          <p:nvPr>
+            <p:ph type="pic" idx="21"/>
+          </p:nvPr>
+        </p:nvSpPr>
+        <p:spPr/>
+        <p:txBody>
+          <a:bodyPr/>
+          <a:lstStyle/>
+          <a:p>
+            <a:endParaRPr lang="es-AR"/>
+          </a:p>
+        </p:txBody>
+      </p:sp>
+      <p:sp>
+        <p:nvSpPr>
+          <p:cNvPr id="8" name="Marcador de texto 7">
+            <a:extLst>
+              <a:ext uri="{FF2B5EF4-FFF2-40B4-BE49-F238E27FC236}">
+                <a16:creationId xmlns:a16="http://schemas.microsoft.com/office/drawing/2014/main" id="{752CD348-AEC7-4C9F-00AF-C636228D2F8B}"/>
+              </a:ext>
+            </a:extLst>
+          </p:cNvPr>
+          <p:cNvSpPr>
+            <a:spLocks noGrp="1"/>
+          </p:cNvSpPr>
+          <p:nvPr>
+            <p:ph type="body" sz="half" idx="19"/>
+          </p:nvPr>
+        </p:nvSpPr>
+        <p:spPr/>
+        <p:txBody>
+          <a:bodyPr/>
+          <a:lstStyle/>
+          <a:p>
+            <a:endParaRPr lang="es-AR"/>
+          </a:p>
+        </p:txBody>
+      </p:sp>
+      <p:sp>
+        <p:nvSpPr>
+          <p:cNvPr id="9" name="Marcador de texto 8">
+            <a:extLst>
+              <a:ext uri="{FF2B5EF4-FFF2-40B4-BE49-F238E27FC236}">
+                <a16:creationId xmlns:a16="http://schemas.microsoft.com/office/drawing/2014/main" id="{19DBD9C8-FFA1-CF47-CC26-2F938F8C8843}"/>
+              </a:ext>
+            </a:extLst>
+          </p:cNvPr>
+          <p:cNvSpPr>
+            <a:spLocks noGrp="1"/>
+          </p:cNvSpPr>
+          <p:nvPr>
+            <p:ph type="body" sz="quarter" idx="13"/>
+          </p:nvPr>
+        </p:nvSpPr>
+        <p:spPr/>
+        <p:txBody>
+          <a:bodyPr/>
+          <a:lstStyle/>
+          <a:p>
+            <a:r>
+              <a:rPr lang="es-AR" dirty="0"/>
+              <a:t>Escenario III</a:t>
+            </a:r>
+          </a:p>
+        </p:txBody>
+      </p:sp>
+      <p:sp>
+        <p:nvSpPr>
+          <p:cNvPr id="10" name="Marcador de posición de imagen 9">
+            <a:extLst>
+              <a:ext uri="{FF2B5EF4-FFF2-40B4-BE49-F238E27FC236}">
+                <a16:creationId xmlns:a16="http://schemas.microsoft.com/office/drawing/2014/main" id="{A616A10C-26F0-942E-66E9-09AA758DF162}"/>
+              </a:ext>
+            </a:extLst>
+          </p:cNvPr>
+          <p:cNvSpPr>
+            <a:spLocks noGrp="1"/>
+          </p:cNvSpPr>
+          <p:nvPr>
+            <p:ph type="pic" idx="22"/>
+          </p:nvPr>
+        </p:nvSpPr>
+        <p:spPr/>
+        <p:txBody>
+          <a:bodyPr/>
+          <a:lstStyle/>
+          <a:p>
+            <a:endParaRPr lang="es-AR"/>
+          </a:p>
+        </p:txBody>
+      </p:sp>
+      <p:sp>
+        <p:nvSpPr>
+          <p:cNvPr id="11" name="Marcador de texto 10">
+            <a:extLst>
+              <a:ext uri="{FF2B5EF4-FFF2-40B4-BE49-F238E27FC236}">
+                <a16:creationId xmlns:a16="http://schemas.microsoft.com/office/drawing/2014/main" id="{B44CD1E5-5B4E-AAE1-7DD8-02614ECA6A46}"/>
+              </a:ext>
+            </a:extLst>
+          </p:cNvPr>
+          <p:cNvSpPr>
+            <a:spLocks noGrp="1"/>
+          </p:cNvSpPr>
+          <p:nvPr>
+            <p:ph type="body" sz="half" idx="20"/>
+          </p:nvPr>
+        </p:nvSpPr>
+        <p:spPr/>
+        <p:txBody>
+          <a:bodyPr/>
+          <a:lstStyle/>
+          <a:p>
+            <a:endParaRPr lang="es-AR"/>
+          </a:p>
+        </p:txBody>
+      </p:sp>
+    </p:spTree>
+    <p:extLst>
+      <p:ext uri="{BB962C8B-B14F-4D97-AF65-F5344CB8AC3E}">
+        <p14:creationId xmlns:p14="http://schemas.microsoft.com/office/powerpoint/2010/main" val="551532599"/>
+      </p:ext>
+    </p:extLst>
+  </p:cSld>
+  <p:clrMapOvr>
+    <a:masterClrMapping/>
+  </p:clrMapOvr>
+  <p:extLst>
+    <p:ext uri="{6950BFC3-D8DA-4A85-94F7-54DA5524770B}">
+      <p188:commentRel xmlns:p188="http://schemas.microsoft.com/office/powerpoint/2018/8/main" r:id="rId2"/>
+    </p:ext>
+  </p:extLst>
+</p:sld>
+</file>
+
 <file path=ppt/slides/slide2.xml><?xml version="1.0" encoding="utf-8"?>
 <p:sld xmlns:a="http://schemas.openxmlformats.org/drawingml/2006/main" xmlns:r="http://schemas.openxmlformats.org/officeDocument/2006/relationships" xmlns:p="http://schemas.openxmlformats.org/presentationml/2006/main">
   <p:cSld>
@@ -6463,6 +9015,423 @@
     <p:extLst>
       <p:ext uri="{BB962C8B-B14F-4D97-AF65-F5344CB8AC3E}">
         <p14:creationId xmlns:p14="http://schemas.microsoft.com/office/powerpoint/2010/main" val="2183427641"/>
+      </p:ext>
+    </p:extLst>
+  </p:cSld>
+  <p:clrMapOvr>
+    <a:masterClrMapping/>
+  </p:clrMapOvr>
+</p:sld>
+</file>
+
+<file path=ppt/slides/slide20.xml><?xml version="1.0" encoding="utf-8"?>
+<p:sld xmlns:a="http://schemas.openxmlformats.org/drawingml/2006/main" xmlns:r="http://schemas.openxmlformats.org/officeDocument/2006/relationships" xmlns:p="http://schemas.openxmlformats.org/presentationml/2006/main">
+  <p:cSld>
+    <p:spTree>
+      <p:nvGrpSpPr>
+        <p:cNvPr id="1" name="">
+          <a:extLst>
+            <a:ext uri="{FF2B5EF4-FFF2-40B4-BE49-F238E27FC236}">
+              <a16:creationId xmlns:a16="http://schemas.microsoft.com/office/drawing/2014/main" id="{9076FB4E-4A06-AB18-CACA-11BE01533C0E}"/>
+            </a:ext>
+          </a:extLst>
+        </p:cNvPr>
+        <p:cNvGrpSpPr/>
+        <p:nvPr/>
+      </p:nvGrpSpPr>
+      <p:grpSpPr>
+        <a:xfrm>
+          <a:off x="0" y="0"/>
+          <a:ext cx="0" cy="0"/>
+          <a:chOff x="0" y="0"/>
+          <a:chExt cx="0" cy="0"/>
+        </a:xfrm>
+      </p:grpSpPr>
+      <p:sp>
+        <p:nvSpPr>
+          <p:cNvPr id="2" name="Título 1">
+            <a:extLst>
+              <a:ext uri="{FF2B5EF4-FFF2-40B4-BE49-F238E27FC236}">
+                <a16:creationId xmlns:a16="http://schemas.microsoft.com/office/drawing/2014/main" id="{87D03882-B272-1518-FA39-D9C3F190EE20}"/>
+              </a:ext>
+            </a:extLst>
+          </p:cNvPr>
+          <p:cNvSpPr>
+            <a:spLocks noGrp="1"/>
+          </p:cNvSpPr>
+          <p:nvPr>
+            <p:ph type="title"/>
+          </p:nvPr>
+        </p:nvSpPr>
+        <p:spPr/>
+        <p:txBody>
+          <a:bodyPr/>
+          <a:lstStyle/>
+          <a:p>
+            <a:r>
+              <a:rPr lang="es-AR" dirty="0"/>
+              <a:t>Porcentaje de flujos arrepentidos</a:t>
+            </a:r>
+          </a:p>
+        </p:txBody>
+      </p:sp>
+      <p:sp>
+        <p:nvSpPr>
+          <p:cNvPr id="3" name="Marcador de texto 2">
+            <a:extLst>
+              <a:ext uri="{FF2B5EF4-FFF2-40B4-BE49-F238E27FC236}">
+                <a16:creationId xmlns:a16="http://schemas.microsoft.com/office/drawing/2014/main" id="{852730CF-A165-7DA8-7D2F-707C05D4CF95}"/>
+              </a:ext>
+            </a:extLst>
+          </p:cNvPr>
+          <p:cNvSpPr>
+            <a:spLocks noGrp="1"/>
+          </p:cNvSpPr>
+          <p:nvPr>
+            <p:ph type="body" idx="1"/>
+          </p:nvPr>
+        </p:nvSpPr>
+        <p:spPr/>
+        <p:txBody>
+          <a:bodyPr/>
+          <a:lstStyle/>
+          <a:p>
+            <a:r>
+              <a:rPr lang="es-AR" dirty="0"/>
+              <a:t>Escenario IV</a:t>
+            </a:r>
+          </a:p>
+        </p:txBody>
+      </p:sp>
+      <p:sp>
+        <p:nvSpPr>
+          <p:cNvPr id="4" name="Marcador de posición de imagen 3">
+            <a:extLst>
+              <a:ext uri="{FF2B5EF4-FFF2-40B4-BE49-F238E27FC236}">
+                <a16:creationId xmlns:a16="http://schemas.microsoft.com/office/drawing/2014/main" id="{819365D8-47AB-EE14-3E5B-83E63293B037}"/>
+              </a:ext>
+            </a:extLst>
+          </p:cNvPr>
+          <p:cNvSpPr>
+            <a:spLocks noGrp="1"/>
+          </p:cNvSpPr>
+          <p:nvPr>
+            <p:ph type="pic" idx="15"/>
+          </p:nvPr>
+        </p:nvSpPr>
+        <p:spPr/>
+        <p:txBody>
+          <a:bodyPr/>
+          <a:lstStyle/>
+          <a:p>
+            <a:endParaRPr lang="es-AR"/>
+          </a:p>
+        </p:txBody>
+      </p:sp>
+      <p:sp>
+        <p:nvSpPr>
+          <p:cNvPr id="5" name="Marcador de texto 4">
+            <a:extLst>
+              <a:ext uri="{FF2B5EF4-FFF2-40B4-BE49-F238E27FC236}">
+                <a16:creationId xmlns:a16="http://schemas.microsoft.com/office/drawing/2014/main" id="{FCA3C01A-4416-AECC-9177-96A355F49D6D}"/>
+              </a:ext>
+            </a:extLst>
+          </p:cNvPr>
+          <p:cNvSpPr>
+            <a:spLocks noGrp="1"/>
+          </p:cNvSpPr>
+          <p:nvPr>
+            <p:ph type="body" sz="half" idx="18"/>
+          </p:nvPr>
+        </p:nvSpPr>
+        <p:spPr/>
+        <p:txBody>
+          <a:bodyPr/>
+          <a:lstStyle/>
+          <a:p>
+            <a:endParaRPr lang="es-AR"/>
+          </a:p>
+        </p:txBody>
+      </p:sp>
+      <p:sp>
+        <p:nvSpPr>
+          <p:cNvPr id="6" name="Marcador de texto 5">
+            <a:extLst>
+              <a:ext uri="{FF2B5EF4-FFF2-40B4-BE49-F238E27FC236}">
+                <a16:creationId xmlns:a16="http://schemas.microsoft.com/office/drawing/2014/main" id="{E9199BCB-9B61-56C6-6B57-E01C133341F1}"/>
+              </a:ext>
+            </a:extLst>
+          </p:cNvPr>
+          <p:cNvSpPr>
+            <a:spLocks noGrp="1"/>
+          </p:cNvSpPr>
+          <p:nvPr>
+            <p:ph type="body" sz="quarter" idx="3"/>
+          </p:nvPr>
+        </p:nvSpPr>
+        <p:spPr/>
+        <p:txBody>
+          <a:bodyPr/>
+          <a:lstStyle/>
+          <a:p>
+            <a:r>
+              <a:rPr lang="es-AR" dirty="0"/>
+              <a:t>Escenario V</a:t>
+            </a:r>
+          </a:p>
+        </p:txBody>
+      </p:sp>
+      <p:sp>
+        <p:nvSpPr>
+          <p:cNvPr id="7" name="Marcador de posición de imagen 6">
+            <a:extLst>
+              <a:ext uri="{FF2B5EF4-FFF2-40B4-BE49-F238E27FC236}">
+                <a16:creationId xmlns:a16="http://schemas.microsoft.com/office/drawing/2014/main" id="{AC1C8B9C-5036-3A9B-6CD1-0F51F13B2C44}"/>
+              </a:ext>
+            </a:extLst>
+          </p:cNvPr>
+          <p:cNvSpPr>
+            <a:spLocks noGrp="1"/>
+          </p:cNvSpPr>
+          <p:nvPr>
+            <p:ph type="pic" idx="21"/>
+          </p:nvPr>
+        </p:nvSpPr>
+        <p:spPr/>
+        <p:txBody>
+          <a:bodyPr/>
+          <a:lstStyle/>
+          <a:p>
+            <a:endParaRPr lang="es-AR"/>
+          </a:p>
+        </p:txBody>
+      </p:sp>
+      <p:sp>
+        <p:nvSpPr>
+          <p:cNvPr id="8" name="Marcador de texto 7">
+            <a:extLst>
+              <a:ext uri="{FF2B5EF4-FFF2-40B4-BE49-F238E27FC236}">
+                <a16:creationId xmlns:a16="http://schemas.microsoft.com/office/drawing/2014/main" id="{3586764B-D001-361E-75CF-878F69EF44C5}"/>
+              </a:ext>
+            </a:extLst>
+          </p:cNvPr>
+          <p:cNvSpPr>
+            <a:spLocks noGrp="1"/>
+          </p:cNvSpPr>
+          <p:nvPr>
+            <p:ph type="body" sz="half" idx="19"/>
+          </p:nvPr>
+        </p:nvSpPr>
+        <p:spPr/>
+        <p:txBody>
+          <a:bodyPr/>
+          <a:lstStyle/>
+          <a:p>
+            <a:endParaRPr lang="es-AR" dirty="0"/>
+          </a:p>
+        </p:txBody>
+      </p:sp>
+    </p:spTree>
+    <p:extLst>
+      <p:ext uri="{BB962C8B-B14F-4D97-AF65-F5344CB8AC3E}">
+        <p14:creationId xmlns:p14="http://schemas.microsoft.com/office/powerpoint/2010/main" val="2158961952"/>
+      </p:ext>
+    </p:extLst>
+  </p:cSld>
+  <p:clrMapOvr>
+    <a:masterClrMapping/>
+  </p:clrMapOvr>
+</p:sld>
+</file>
+
+<file path=ppt/slides/slide21.xml><?xml version="1.0" encoding="utf-8"?>
+<p:sld xmlns:a="http://schemas.openxmlformats.org/drawingml/2006/main" xmlns:r="http://schemas.openxmlformats.org/officeDocument/2006/relationships" xmlns:p="http://schemas.openxmlformats.org/presentationml/2006/main">
+  <p:cSld>
+    <p:spTree>
+      <p:nvGrpSpPr>
+        <p:cNvPr id="1" name="">
+          <a:extLst>
+            <a:ext uri="{FF2B5EF4-FFF2-40B4-BE49-F238E27FC236}">
+              <a16:creationId xmlns:a16="http://schemas.microsoft.com/office/drawing/2014/main" id="{F12C1B4C-7BC0-DABA-CFF8-0F2008BB5FC3}"/>
+            </a:ext>
+          </a:extLst>
+        </p:cNvPr>
+        <p:cNvGrpSpPr/>
+        <p:nvPr/>
+      </p:nvGrpSpPr>
+      <p:grpSpPr>
+        <a:xfrm>
+          <a:off x="0" y="0"/>
+          <a:ext cx="0" cy="0"/>
+          <a:chOff x="0" y="0"/>
+          <a:chExt cx="0" cy="0"/>
+        </a:xfrm>
+      </p:grpSpPr>
+      <p:sp>
+        <p:nvSpPr>
+          <p:cNvPr id="2" name="Título 1">
+            <a:extLst>
+              <a:ext uri="{FF2B5EF4-FFF2-40B4-BE49-F238E27FC236}">
+                <a16:creationId xmlns:a16="http://schemas.microsoft.com/office/drawing/2014/main" id="{89319360-EF0C-B1AD-41B0-1EBF58E06A13}"/>
+              </a:ext>
+            </a:extLst>
+          </p:cNvPr>
+          <p:cNvSpPr>
+            <a:spLocks noGrp="1"/>
+          </p:cNvSpPr>
+          <p:nvPr>
+            <p:ph type="title"/>
+          </p:nvPr>
+        </p:nvSpPr>
+        <p:spPr/>
+        <p:txBody>
+          <a:bodyPr/>
+          <a:lstStyle/>
+          <a:p>
+            <a:r>
+              <a:rPr lang="es-AR" dirty="0"/>
+              <a:t>Conclusión</a:t>
+            </a:r>
+          </a:p>
+        </p:txBody>
+      </p:sp>
+      <p:sp>
+        <p:nvSpPr>
+          <p:cNvPr id="3" name="Marcador de texto 2">
+            <a:extLst>
+              <a:ext uri="{FF2B5EF4-FFF2-40B4-BE49-F238E27FC236}">
+                <a16:creationId xmlns:a16="http://schemas.microsoft.com/office/drawing/2014/main" id="{E398E156-A7CE-A4A7-8D5E-D14163C866EA}"/>
+              </a:ext>
+            </a:extLst>
+          </p:cNvPr>
+          <p:cNvSpPr>
+            <a:spLocks noGrp="1"/>
+          </p:cNvSpPr>
+          <p:nvPr>
+            <p:ph type="body" idx="1"/>
+          </p:nvPr>
+        </p:nvSpPr>
+        <p:spPr/>
+        <p:txBody>
+          <a:bodyPr/>
+          <a:lstStyle/>
+          <a:p>
+            <a:endParaRPr lang="es-AR" dirty="0"/>
+          </a:p>
+        </p:txBody>
+      </p:sp>
+    </p:spTree>
+    <p:extLst>
+      <p:ext uri="{BB962C8B-B14F-4D97-AF65-F5344CB8AC3E}">
+        <p14:creationId xmlns:p14="http://schemas.microsoft.com/office/powerpoint/2010/main" val="1095173537"/>
+      </p:ext>
+    </p:extLst>
+  </p:cSld>
+  <p:clrMapOvr>
+    <a:masterClrMapping/>
+  </p:clrMapOvr>
+</p:sld>
+</file>
+
+<file path=ppt/slides/slide22.xml><?xml version="1.0" encoding="utf-8"?>
+<p:sld xmlns:a="http://schemas.openxmlformats.org/drawingml/2006/main" xmlns:r="http://schemas.openxmlformats.org/officeDocument/2006/relationships" xmlns:p="http://schemas.openxmlformats.org/presentationml/2006/main">
+  <p:cSld>
+    <p:spTree>
+      <p:nvGrpSpPr>
+        <p:cNvPr id="1" name=""/>
+        <p:cNvGrpSpPr/>
+        <p:nvPr/>
+      </p:nvGrpSpPr>
+      <p:grpSpPr>
+        <a:xfrm>
+          <a:off x="0" y="0"/>
+          <a:ext cx="0" cy="0"/>
+          <a:chOff x="0" y="0"/>
+          <a:chExt cx="0" cy="0"/>
+        </a:xfrm>
+      </p:grpSpPr>
+      <p:sp>
+        <p:nvSpPr>
+          <p:cNvPr id="2" name="Título 1">
+            <a:extLst>
+              <a:ext uri="{FF2B5EF4-FFF2-40B4-BE49-F238E27FC236}">
+                <a16:creationId xmlns:a16="http://schemas.microsoft.com/office/drawing/2014/main" id="{3357249E-D4D0-E42C-770D-A1205D2557DB}"/>
+              </a:ext>
+            </a:extLst>
+          </p:cNvPr>
+          <p:cNvSpPr>
+            <a:spLocks noGrp="1"/>
+          </p:cNvSpPr>
+          <p:nvPr>
+            <p:ph type="title"/>
+          </p:nvPr>
+        </p:nvSpPr>
+        <p:spPr/>
+        <p:txBody>
+          <a:bodyPr/>
+          <a:lstStyle/>
+          <a:p>
+            <a:endParaRPr lang="es-AR" dirty="0"/>
+          </a:p>
+        </p:txBody>
+      </p:sp>
+      <p:sp>
+        <p:nvSpPr>
+          <p:cNvPr id="3" name="Marcador de texto 2">
+            <a:extLst>
+              <a:ext uri="{FF2B5EF4-FFF2-40B4-BE49-F238E27FC236}">
+                <a16:creationId xmlns:a16="http://schemas.microsoft.com/office/drawing/2014/main" id="{3462BB5D-9390-742A-E286-F3A2A342F919}"/>
+              </a:ext>
+            </a:extLst>
+          </p:cNvPr>
+          <p:cNvSpPr>
+            <a:spLocks noGrp="1"/>
+          </p:cNvSpPr>
+          <p:nvPr>
+            <p:ph type="body" sz="half" idx="13"/>
+          </p:nvPr>
+        </p:nvSpPr>
+        <p:spPr/>
+        <p:txBody>
+          <a:bodyPr/>
+          <a:lstStyle/>
+          <a:p>
+            <a:r>
+              <a:rPr lang="es-AR" dirty="0"/>
+              <a:t>Recomendación de la acción a tomar</a:t>
+            </a:r>
+          </a:p>
+        </p:txBody>
+      </p:sp>
+      <p:sp>
+        <p:nvSpPr>
+          <p:cNvPr id="4" name="Marcador de texto 3">
+            <a:extLst>
+              <a:ext uri="{FF2B5EF4-FFF2-40B4-BE49-F238E27FC236}">
+                <a16:creationId xmlns:a16="http://schemas.microsoft.com/office/drawing/2014/main" id="{E22E279D-A629-520A-CA16-058B3731E45D}"/>
+              </a:ext>
+            </a:extLst>
+          </p:cNvPr>
+          <p:cNvSpPr>
+            <a:spLocks noGrp="1"/>
+          </p:cNvSpPr>
+          <p:nvPr>
+            <p:ph type="body" sz="half" idx="2"/>
+          </p:nvPr>
+        </p:nvSpPr>
+        <p:spPr/>
+        <p:txBody>
+          <a:bodyPr/>
+          <a:lstStyle/>
+          <a:p>
+            <a:endParaRPr lang="es-AR" dirty="0"/>
+          </a:p>
+        </p:txBody>
+      </p:sp>
+    </p:spTree>
+    <p:extLst>
+      <p:ext uri="{BB962C8B-B14F-4D97-AF65-F5344CB8AC3E}">
+        <p14:creationId xmlns:p14="http://schemas.microsoft.com/office/powerpoint/2010/main" val="3924450678"/>
       </p:ext>
     </p:extLst>
   </p:cSld>

</xml_diff>